<commit_message>
L1.6R dual-coding remediation evidence
</commit_message>
<xml_diff>
--- a/Boek 1 - Grondslagen, vraag en aanbod/1.1 Hoofdstuk Economisch denken en rekenen/1.1.3 Grafieken en tabellen/1.1.3 Grafieken en tabellen – presentatie.pptx
+++ b/Boek 1 - Grondslagen, vraag en aanbod/1.1 Hoofdstuk Economisch denken en rekenen/1.1.3 Grafieken en tabellen/1.1.3 Grafieken en tabellen – presentatie.pptx
@@ -1349,20 +1349,18 @@
         </p:nvSpPr>
         <p:spPr>
           <a:xfrm>
-            <a:off x="914400" y="1965960"/>
-            <a:ext cx="10058400" cy="457200"/>
-          </a:xfrm>
-          <a:prstGeom prst="roundRect">
-            <a:avLst>
-              <a:gd name="adj" fmla="val 16000"/>
-            </a:avLst>
-          </a:prstGeom>
-          <a:solidFill>
-            <a:srgbClr val="ECFEFF"/>
+            <a:off x="822960" y="1874520"/>
+            <a:ext cx="2011680" cy="373380"/>
+          </a:xfrm>
+          <a:prstGeom prst="rect">
+            <a:avLst/>
+          </a:prstGeom>
+          <a:solidFill>
+            <a:srgbClr val="DDF7EF"/>
           </a:solidFill>
           <a:ln w="12700">
             <a:solidFill>
-              <a:srgbClr val="BAE6FD"/>
+              <a:srgbClr val="CBD5E1"/>
             </a:solidFill>
             <a:prstDash val="solid"/>
           </a:ln>
@@ -1376,8 +1374,8 @@
         </p:nvSpPr>
         <p:spPr>
           <a:xfrm>
-            <a:off x="1143000" y="2084832"/>
-            <a:ext cx="9509760" cy="182880"/>
+            <a:off x="877824" y="1938528"/>
+            <a:ext cx="1901952" cy="300228"/>
           </a:xfrm>
           <a:prstGeom prst="rect">
             <a:avLst/>
@@ -1395,14 +1393,14 @@
               <a:buNone/>
             </a:pPr>
             <a:r>
-              <a:rPr lang="en-US" sz="1500" dirty="0">
+              <a:rPr lang="en-US" sz="1100" b="1" dirty="0">
                 <a:solidFill>
                   <a:srgbClr val="102A43"/>
                 </a:solidFill>
               </a:rPr>
-              <a:t>Prijs en aantal verkochte ijsjes staan in verschillende kolommen.</a:t>
-            </a:r>
-            <a:endParaRPr lang="en-US" sz="1500" dirty="0"/>
+              <a:t>Prijs</a:t>
+            </a:r>
+            <a:endParaRPr lang="en-US" sz="1100" dirty="0"/>
           </a:p>
         </p:txBody>
       </p:sp>
@@ -1414,20 +1412,18 @@
         </p:nvSpPr>
         <p:spPr>
           <a:xfrm>
-            <a:off x="914400" y="2679192"/>
-            <a:ext cx="10058400" cy="457200"/>
-          </a:xfrm>
-          <a:prstGeom prst="roundRect">
-            <a:avLst>
-              <a:gd name="adj" fmla="val 16000"/>
-            </a:avLst>
-          </a:prstGeom>
-          <a:solidFill>
-            <a:srgbClr val="FFFFFF"/>
+            <a:off x="2834640" y="1874520"/>
+            <a:ext cx="2011680" cy="373380"/>
+          </a:xfrm>
+          <a:prstGeom prst="rect">
+            <a:avLst/>
+          </a:prstGeom>
+          <a:solidFill>
+            <a:srgbClr val="DDF7EF"/>
           </a:solidFill>
           <a:ln w="12700">
             <a:solidFill>
-              <a:srgbClr val="BAE6FD"/>
+              <a:srgbClr val="CBD5E1"/>
             </a:solidFill>
             <a:prstDash val="solid"/>
           </a:ln>
@@ -1441,8 +1437,8 @@
         </p:nvSpPr>
         <p:spPr>
           <a:xfrm>
-            <a:off x="1143000" y="2798064"/>
-            <a:ext cx="9509760" cy="182880"/>
+            <a:off x="2889504" y="1938528"/>
+            <a:ext cx="1901952" cy="300228"/>
           </a:xfrm>
           <a:prstGeom prst="rect">
             <a:avLst/>
@@ -1460,14 +1456,14 @@
               <a:buNone/>
             </a:pPr>
             <a:r>
-              <a:rPr lang="en-US" sz="1500" dirty="0">
+              <a:rPr lang="en-US" sz="1100" b="1" dirty="0">
                 <a:solidFill>
                   <a:srgbClr val="102A43"/>
                 </a:solidFill>
               </a:rPr>
-              <a:t>Een tabel ordent de data; een grafiek maakt het verband zichtbaar.</a:t>
-            </a:r>
-            <a:endParaRPr lang="en-US" sz="1500" dirty="0"/>
+              <a:t>Verkoop</a:t>
+            </a:r>
+            <a:endParaRPr lang="en-US" sz="1100" dirty="0"/>
           </a:p>
         </p:txBody>
       </p:sp>
@@ -1479,20 +1475,18 @@
         </p:nvSpPr>
         <p:spPr>
           <a:xfrm>
-            <a:off x="914400" y="3392424"/>
-            <a:ext cx="10058400" cy="457200"/>
-          </a:xfrm>
-          <a:prstGeom prst="roundRect">
-            <a:avLst>
-              <a:gd name="adj" fmla="val 16000"/>
-            </a:avLst>
-          </a:prstGeom>
-          <a:solidFill>
-            <a:srgbClr val="ECFEFF"/>
+            <a:off x="822960" y="2247900"/>
+            <a:ext cx="2011680" cy="373380"/>
+          </a:xfrm>
+          <a:prstGeom prst="rect">
+            <a:avLst/>
+          </a:prstGeom>
+          <a:solidFill>
+            <a:srgbClr val="FFF4CC"/>
           </a:solidFill>
           <a:ln w="12700">
             <a:solidFill>
-              <a:srgbClr val="BAE6FD"/>
+              <a:srgbClr val="CBD5E1"/>
             </a:solidFill>
             <a:prstDash val="solid"/>
           </a:ln>
@@ -1506,8 +1500,8 @@
         </p:nvSpPr>
         <p:spPr>
           <a:xfrm>
-            <a:off x="1143000" y="3511296"/>
-            <a:ext cx="9509760" cy="182880"/>
+            <a:off x="877824" y="2311908"/>
+            <a:ext cx="1901952" cy="300228"/>
           </a:xfrm>
           <a:prstGeom prst="rect">
             <a:avLst/>
@@ -1525,14 +1519,1172 @@
               <a:buNone/>
             </a:pPr>
             <a:r>
-              <a:rPr lang="en-US" sz="1500" dirty="0">
+              <a:rPr lang="en-US" sz="1000" b="1" dirty="0">
                 <a:solidFill>
                   <a:srgbClr val="102A43"/>
                 </a:solidFill>
               </a:rPr>
+              <a:t>EUR 1,00</a:t>
+            </a:r>
+            <a:endParaRPr lang="en-US" sz="1000" dirty="0"/>
+          </a:p>
+        </p:txBody>
+      </p:sp>
+      <p:sp>
+        <p:nvSpPr>
+          <p:cNvPr id="11" name="Shape 9"/>
+          <p:cNvSpPr/>
+          <p:nvPr/>
+        </p:nvSpPr>
+        <p:spPr>
+          <a:xfrm>
+            <a:off x="2834640" y="2247900"/>
+            <a:ext cx="2011680" cy="373380"/>
+          </a:xfrm>
+          <a:prstGeom prst="rect">
+            <a:avLst/>
+          </a:prstGeom>
+          <a:solidFill>
+            <a:srgbClr val="FFF4CC"/>
+          </a:solidFill>
+          <a:ln w="12700">
+            <a:solidFill>
+              <a:srgbClr val="CBD5E1"/>
+            </a:solidFill>
+            <a:prstDash val="solid"/>
+          </a:ln>
+        </p:spPr>
+      </p:sp>
+      <p:sp>
+        <p:nvSpPr>
+          <p:cNvPr id="12" name="Text 10"/>
+          <p:cNvSpPr/>
+          <p:nvPr/>
+        </p:nvSpPr>
+        <p:spPr>
+          <a:xfrm>
+            <a:off x="2889504" y="2311908"/>
+            <a:ext cx="1901952" cy="300228"/>
+          </a:xfrm>
+          <a:prstGeom prst="rect">
+            <a:avLst/>
+          </a:prstGeom>
+          <a:noFill/>
+          <a:ln/>
+        </p:spPr>
+        <p:txBody>
+          <a:bodyPr wrap="square" lIns="0" tIns="0" rIns="0" bIns="0" rtlCol="0" anchor="ctr">
+            <a:normAutofit/>
+          </a:bodyPr>
+          <a:lstStyle/>
+          <a:p>
+            <a:pPr indent="0" marL="0">
+              <a:buNone/>
+            </a:pPr>
+            <a:r>
+              <a:rPr lang="en-US" sz="1000" b="1" dirty="0">
+                <a:solidFill>
+                  <a:srgbClr val="102A43"/>
+                </a:solidFill>
+              </a:rPr>
+              <a:t>500</a:t>
+            </a:r>
+            <a:endParaRPr lang="en-US" sz="1000" dirty="0"/>
+          </a:p>
+        </p:txBody>
+      </p:sp>
+      <p:sp>
+        <p:nvSpPr>
+          <p:cNvPr id="13" name="Shape 11"/>
+          <p:cNvSpPr/>
+          <p:nvPr/>
+        </p:nvSpPr>
+        <p:spPr>
+          <a:xfrm>
+            <a:off x="822960" y="2621280"/>
+            <a:ext cx="2011680" cy="373380"/>
+          </a:xfrm>
+          <a:prstGeom prst="rect">
+            <a:avLst/>
+          </a:prstGeom>
+          <a:solidFill>
+            <a:srgbClr val="FFFFFF"/>
+          </a:solidFill>
+          <a:ln w="12700">
+            <a:solidFill>
+              <a:srgbClr val="CBD5E1"/>
+            </a:solidFill>
+            <a:prstDash val="solid"/>
+          </a:ln>
+        </p:spPr>
+      </p:sp>
+      <p:sp>
+        <p:nvSpPr>
+          <p:cNvPr id="14" name="Text 12"/>
+          <p:cNvSpPr/>
+          <p:nvPr/>
+        </p:nvSpPr>
+        <p:spPr>
+          <a:xfrm>
+            <a:off x="877824" y="2685288"/>
+            <a:ext cx="1901952" cy="300228"/>
+          </a:xfrm>
+          <a:prstGeom prst="rect">
+            <a:avLst/>
+          </a:prstGeom>
+          <a:noFill/>
+          <a:ln/>
+        </p:spPr>
+        <p:txBody>
+          <a:bodyPr wrap="square" lIns="0" tIns="0" rIns="0" bIns="0" rtlCol="0" anchor="ctr">
+            <a:normAutofit/>
+          </a:bodyPr>
+          <a:lstStyle/>
+          <a:p>
+            <a:pPr indent="0" marL="0">
+              <a:buNone/>
+            </a:pPr>
+            <a:r>
+              <a:rPr lang="en-US" sz="1000" dirty="0">
+                <a:solidFill>
+                  <a:srgbClr val="102A43"/>
+                </a:solidFill>
+              </a:rPr>
+              <a:t>EUR 1,50</a:t>
+            </a:r>
+            <a:endParaRPr lang="en-US" sz="1000" dirty="0"/>
+          </a:p>
+        </p:txBody>
+      </p:sp>
+      <p:sp>
+        <p:nvSpPr>
+          <p:cNvPr id="15" name="Shape 13"/>
+          <p:cNvSpPr/>
+          <p:nvPr/>
+        </p:nvSpPr>
+        <p:spPr>
+          <a:xfrm>
+            <a:off x="2834640" y="2621280"/>
+            <a:ext cx="2011680" cy="373380"/>
+          </a:xfrm>
+          <a:prstGeom prst="rect">
+            <a:avLst/>
+          </a:prstGeom>
+          <a:solidFill>
+            <a:srgbClr val="FFFFFF"/>
+          </a:solidFill>
+          <a:ln w="12700">
+            <a:solidFill>
+              <a:srgbClr val="CBD5E1"/>
+            </a:solidFill>
+            <a:prstDash val="solid"/>
+          </a:ln>
+        </p:spPr>
+      </p:sp>
+      <p:sp>
+        <p:nvSpPr>
+          <p:cNvPr id="16" name="Text 14"/>
+          <p:cNvSpPr/>
+          <p:nvPr/>
+        </p:nvSpPr>
+        <p:spPr>
+          <a:xfrm>
+            <a:off x="2889504" y="2685288"/>
+            <a:ext cx="1901952" cy="300228"/>
+          </a:xfrm>
+          <a:prstGeom prst="rect">
+            <a:avLst/>
+          </a:prstGeom>
+          <a:noFill/>
+          <a:ln/>
+        </p:spPr>
+        <p:txBody>
+          <a:bodyPr wrap="square" lIns="0" tIns="0" rIns="0" bIns="0" rtlCol="0" anchor="ctr">
+            <a:normAutofit/>
+          </a:bodyPr>
+          <a:lstStyle/>
+          <a:p>
+            <a:pPr indent="0" marL="0">
+              <a:buNone/>
+            </a:pPr>
+            <a:r>
+              <a:rPr lang="en-US" sz="1000" dirty="0">
+                <a:solidFill>
+                  <a:srgbClr val="102A43"/>
+                </a:solidFill>
+              </a:rPr>
+              <a:t>400</a:t>
+            </a:r>
+            <a:endParaRPr lang="en-US" sz="1000" dirty="0"/>
+          </a:p>
+        </p:txBody>
+      </p:sp>
+      <p:sp>
+        <p:nvSpPr>
+          <p:cNvPr id="17" name="Shape 15"/>
+          <p:cNvSpPr/>
+          <p:nvPr/>
+        </p:nvSpPr>
+        <p:spPr>
+          <a:xfrm>
+            <a:off x="822960" y="2994660"/>
+            <a:ext cx="2011680" cy="373380"/>
+          </a:xfrm>
+          <a:prstGeom prst="rect">
+            <a:avLst/>
+          </a:prstGeom>
+          <a:solidFill>
+            <a:srgbClr val="FFF4CC"/>
+          </a:solidFill>
+          <a:ln w="12700">
+            <a:solidFill>
+              <a:srgbClr val="CBD5E1"/>
+            </a:solidFill>
+            <a:prstDash val="solid"/>
+          </a:ln>
+        </p:spPr>
+      </p:sp>
+      <p:sp>
+        <p:nvSpPr>
+          <p:cNvPr id="18" name="Text 16"/>
+          <p:cNvSpPr/>
+          <p:nvPr/>
+        </p:nvSpPr>
+        <p:spPr>
+          <a:xfrm>
+            <a:off x="877824" y="3058668"/>
+            <a:ext cx="1901952" cy="300228"/>
+          </a:xfrm>
+          <a:prstGeom prst="rect">
+            <a:avLst/>
+          </a:prstGeom>
+          <a:noFill/>
+          <a:ln/>
+        </p:spPr>
+        <p:txBody>
+          <a:bodyPr wrap="square" lIns="0" tIns="0" rIns="0" bIns="0" rtlCol="0" anchor="ctr">
+            <a:normAutofit/>
+          </a:bodyPr>
+          <a:lstStyle/>
+          <a:p>
+            <a:pPr indent="0" marL="0">
+              <a:buNone/>
+            </a:pPr>
+            <a:r>
+              <a:rPr lang="en-US" sz="1000" b="1" dirty="0">
+                <a:solidFill>
+                  <a:srgbClr val="102A43"/>
+                </a:solidFill>
+              </a:rPr>
+              <a:t>EUR 2,00</a:t>
+            </a:r>
+            <a:endParaRPr lang="en-US" sz="1000" dirty="0"/>
+          </a:p>
+        </p:txBody>
+      </p:sp>
+      <p:sp>
+        <p:nvSpPr>
+          <p:cNvPr id="19" name="Shape 17"/>
+          <p:cNvSpPr/>
+          <p:nvPr/>
+        </p:nvSpPr>
+        <p:spPr>
+          <a:xfrm>
+            <a:off x="2834640" y="2994660"/>
+            <a:ext cx="2011680" cy="373380"/>
+          </a:xfrm>
+          <a:prstGeom prst="rect">
+            <a:avLst/>
+          </a:prstGeom>
+          <a:solidFill>
+            <a:srgbClr val="FFF4CC"/>
+          </a:solidFill>
+          <a:ln w="12700">
+            <a:solidFill>
+              <a:srgbClr val="CBD5E1"/>
+            </a:solidFill>
+            <a:prstDash val="solid"/>
+          </a:ln>
+        </p:spPr>
+      </p:sp>
+      <p:sp>
+        <p:nvSpPr>
+          <p:cNvPr id="20" name="Text 18"/>
+          <p:cNvSpPr/>
+          <p:nvPr/>
+        </p:nvSpPr>
+        <p:spPr>
+          <a:xfrm>
+            <a:off x="2889504" y="3058668"/>
+            <a:ext cx="1901952" cy="300228"/>
+          </a:xfrm>
+          <a:prstGeom prst="rect">
+            <a:avLst/>
+          </a:prstGeom>
+          <a:noFill/>
+          <a:ln/>
+        </p:spPr>
+        <p:txBody>
+          <a:bodyPr wrap="square" lIns="0" tIns="0" rIns="0" bIns="0" rtlCol="0" anchor="ctr">
+            <a:normAutofit/>
+          </a:bodyPr>
+          <a:lstStyle/>
+          <a:p>
+            <a:pPr indent="0" marL="0">
+              <a:buNone/>
+            </a:pPr>
+            <a:r>
+              <a:rPr lang="en-US" sz="1000" b="1" dirty="0">
+                <a:solidFill>
+                  <a:srgbClr val="102A43"/>
+                </a:solidFill>
+              </a:rPr>
+              <a:t>300</a:t>
+            </a:r>
+            <a:endParaRPr lang="en-US" sz="1000" dirty="0"/>
+          </a:p>
+        </p:txBody>
+      </p:sp>
+      <p:sp>
+        <p:nvSpPr>
+          <p:cNvPr id="21" name="Shape 19"/>
+          <p:cNvSpPr/>
+          <p:nvPr/>
+        </p:nvSpPr>
+        <p:spPr>
+          <a:xfrm>
+            <a:off x="822960" y="3368040"/>
+            <a:ext cx="2011680" cy="373380"/>
+          </a:xfrm>
+          <a:prstGeom prst="rect">
+            <a:avLst/>
+          </a:prstGeom>
+          <a:solidFill>
+            <a:srgbClr val="FFFFFF"/>
+          </a:solidFill>
+          <a:ln w="12700">
+            <a:solidFill>
+              <a:srgbClr val="CBD5E1"/>
+            </a:solidFill>
+            <a:prstDash val="solid"/>
+          </a:ln>
+        </p:spPr>
+      </p:sp>
+      <p:sp>
+        <p:nvSpPr>
+          <p:cNvPr id="22" name="Text 20"/>
+          <p:cNvSpPr/>
+          <p:nvPr/>
+        </p:nvSpPr>
+        <p:spPr>
+          <a:xfrm>
+            <a:off x="877824" y="3432048"/>
+            <a:ext cx="1901952" cy="300228"/>
+          </a:xfrm>
+          <a:prstGeom prst="rect">
+            <a:avLst/>
+          </a:prstGeom>
+          <a:noFill/>
+          <a:ln/>
+        </p:spPr>
+        <p:txBody>
+          <a:bodyPr wrap="square" lIns="0" tIns="0" rIns="0" bIns="0" rtlCol="0" anchor="ctr">
+            <a:normAutofit/>
+          </a:bodyPr>
+          <a:lstStyle/>
+          <a:p>
+            <a:pPr indent="0" marL="0">
+              <a:buNone/>
+            </a:pPr>
+            <a:r>
+              <a:rPr lang="en-US" sz="1000" dirty="0">
+                <a:solidFill>
+                  <a:srgbClr val="102A43"/>
+                </a:solidFill>
+              </a:rPr>
+              <a:t>EUR 2,50</a:t>
+            </a:r>
+            <a:endParaRPr lang="en-US" sz="1000" dirty="0"/>
+          </a:p>
+        </p:txBody>
+      </p:sp>
+      <p:sp>
+        <p:nvSpPr>
+          <p:cNvPr id="23" name="Shape 21"/>
+          <p:cNvSpPr/>
+          <p:nvPr/>
+        </p:nvSpPr>
+        <p:spPr>
+          <a:xfrm>
+            <a:off x="2834640" y="3368040"/>
+            <a:ext cx="2011680" cy="373380"/>
+          </a:xfrm>
+          <a:prstGeom prst="rect">
+            <a:avLst/>
+          </a:prstGeom>
+          <a:solidFill>
+            <a:srgbClr val="FFFFFF"/>
+          </a:solidFill>
+          <a:ln w="12700">
+            <a:solidFill>
+              <a:srgbClr val="CBD5E1"/>
+            </a:solidFill>
+            <a:prstDash val="solid"/>
+          </a:ln>
+        </p:spPr>
+      </p:sp>
+      <p:sp>
+        <p:nvSpPr>
+          <p:cNvPr id="24" name="Text 22"/>
+          <p:cNvSpPr/>
+          <p:nvPr/>
+        </p:nvSpPr>
+        <p:spPr>
+          <a:xfrm>
+            <a:off x="2889504" y="3432048"/>
+            <a:ext cx="1901952" cy="300228"/>
+          </a:xfrm>
+          <a:prstGeom prst="rect">
+            <a:avLst/>
+          </a:prstGeom>
+          <a:noFill/>
+          <a:ln/>
+        </p:spPr>
+        <p:txBody>
+          <a:bodyPr wrap="square" lIns="0" tIns="0" rIns="0" bIns="0" rtlCol="0" anchor="ctr">
+            <a:normAutofit/>
+          </a:bodyPr>
+          <a:lstStyle/>
+          <a:p>
+            <a:pPr indent="0" marL="0">
+              <a:buNone/>
+            </a:pPr>
+            <a:r>
+              <a:rPr lang="en-US" sz="1000" dirty="0">
+                <a:solidFill>
+                  <a:srgbClr val="102A43"/>
+                </a:solidFill>
+              </a:rPr>
+              <a:t>200</a:t>
+            </a:r>
+            <a:endParaRPr lang="en-US" sz="1000" dirty="0"/>
+          </a:p>
+        </p:txBody>
+      </p:sp>
+      <p:sp>
+        <p:nvSpPr>
+          <p:cNvPr id="25" name="Shape 23"/>
+          <p:cNvSpPr/>
+          <p:nvPr/>
+        </p:nvSpPr>
+        <p:spPr>
+          <a:xfrm>
+            <a:off x="822960" y="3741420"/>
+            <a:ext cx="2011680" cy="373380"/>
+          </a:xfrm>
+          <a:prstGeom prst="rect">
+            <a:avLst/>
+          </a:prstGeom>
+          <a:solidFill>
+            <a:srgbClr val="FFFFFF"/>
+          </a:solidFill>
+          <a:ln w="12700">
+            <a:solidFill>
+              <a:srgbClr val="CBD5E1"/>
+            </a:solidFill>
+            <a:prstDash val="solid"/>
+          </a:ln>
+        </p:spPr>
+      </p:sp>
+      <p:sp>
+        <p:nvSpPr>
+          <p:cNvPr id="26" name="Text 24"/>
+          <p:cNvSpPr/>
+          <p:nvPr/>
+        </p:nvSpPr>
+        <p:spPr>
+          <a:xfrm>
+            <a:off x="877824" y="3805428"/>
+            <a:ext cx="1901952" cy="300228"/>
+          </a:xfrm>
+          <a:prstGeom prst="rect">
+            <a:avLst/>
+          </a:prstGeom>
+          <a:noFill/>
+          <a:ln/>
+        </p:spPr>
+        <p:txBody>
+          <a:bodyPr wrap="square" lIns="0" tIns="0" rIns="0" bIns="0" rtlCol="0" anchor="ctr">
+            <a:normAutofit/>
+          </a:bodyPr>
+          <a:lstStyle/>
+          <a:p>
+            <a:pPr indent="0" marL="0">
+              <a:buNone/>
+            </a:pPr>
+            <a:r>
+              <a:rPr lang="en-US" sz="1000" dirty="0">
+                <a:solidFill>
+                  <a:srgbClr val="102A43"/>
+                </a:solidFill>
+              </a:rPr>
+              <a:t>EUR 3,00</a:t>
+            </a:r>
+            <a:endParaRPr lang="en-US" sz="1000" dirty="0"/>
+          </a:p>
+        </p:txBody>
+      </p:sp>
+      <p:sp>
+        <p:nvSpPr>
+          <p:cNvPr id="27" name="Shape 25"/>
+          <p:cNvSpPr/>
+          <p:nvPr/>
+        </p:nvSpPr>
+        <p:spPr>
+          <a:xfrm>
+            <a:off x="2834640" y="3741420"/>
+            <a:ext cx="2011680" cy="373380"/>
+          </a:xfrm>
+          <a:prstGeom prst="rect">
+            <a:avLst/>
+          </a:prstGeom>
+          <a:solidFill>
+            <a:srgbClr val="FFFFFF"/>
+          </a:solidFill>
+          <a:ln w="12700">
+            <a:solidFill>
+              <a:srgbClr val="CBD5E1"/>
+            </a:solidFill>
+            <a:prstDash val="solid"/>
+          </a:ln>
+        </p:spPr>
+      </p:sp>
+      <p:sp>
+        <p:nvSpPr>
+          <p:cNvPr id="28" name="Text 26"/>
+          <p:cNvSpPr/>
+          <p:nvPr/>
+        </p:nvSpPr>
+        <p:spPr>
+          <a:xfrm>
+            <a:off x="2889504" y="3805428"/>
+            <a:ext cx="1901952" cy="300228"/>
+          </a:xfrm>
+          <a:prstGeom prst="rect">
+            <a:avLst/>
+          </a:prstGeom>
+          <a:noFill/>
+          <a:ln/>
+        </p:spPr>
+        <p:txBody>
+          <a:bodyPr wrap="square" lIns="0" tIns="0" rIns="0" bIns="0" rtlCol="0" anchor="ctr">
+            <a:normAutofit/>
+          </a:bodyPr>
+          <a:lstStyle/>
+          <a:p>
+            <a:pPr indent="0" marL="0">
+              <a:buNone/>
+            </a:pPr>
+            <a:r>
+              <a:rPr lang="en-US" sz="1000" dirty="0">
+                <a:solidFill>
+                  <a:srgbClr val="102A43"/>
+                </a:solidFill>
+              </a:rPr>
+              <a:t>100</a:t>
+            </a:r>
+            <a:endParaRPr lang="en-US" sz="1000" dirty="0"/>
+          </a:p>
+        </p:txBody>
+      </p:sp>
+      <p:sp>
+        <p:nvSpPr>
+          <p:cNvPr id="29" name="Shape 27"/>
+          <p:cNvSpPr/>
+          <p:nvPr/>
+        </p:nvSpPr>
+        <p:spPr>
+          <a:xfrm>
+            <a:off x="5669280" y="1874520"/>
+            <a:ext cx="5029200" cy="2240280"/>
+          </a:xfrm>
+          <a:prstGeom prst="rect">
+            <a:avLst/>
+          </a:prstGeom>
+          <a:solidFill>
+            <a:srgbClr val="FFFFFF"/>
+          </a:solidFill>
+          <a:ln w="12700">
+            <a:solidFill>
+              <a:srgbClr val="CBD5E1"/>
+            </a:solidFill>
+            <a:prstDash val="solid"/>
+          </a:ln>
+        </p:spPr>
+      </p:sp>
+      <p:sp>
+        <p:nvSpPr>
+          <p:cNvPr id="30" name="Shape 28"/>
+          <p:cNvSpPr/>
+          <p:nvPr/>
+        </p:nvSpPr>
+        <p:spPr>
+          <a:xfrm>
+            <a:off x="6172200" y="3703320"/>
+            <a:ext cx="4251960" cy="0"/>
+          </a:xfrm>
+          <a:prstGeom prst="line">
+            <a:avLst/>
+          </a:prstGeom>
+          <a:noFill/>
+          <a:ln w="17780">
+            <a:solidFill>
+              <a:srgbClr val="102A43"/>
+            </a:solidFill>
+            <a:prstDash val="solid"/>
+          </a:ln>
+        </p:spPr>
+      </p:sp>
+      <p:sp>
+        <p:nvSpPr>
+          <p:cNvPr id="31" name="Shape 29"/>
+          <p:cNvSpPr/>
+          <p:nvPr/>
+        </p:nvSpPr>
+        <p:spPr>
+          <a:xfrm>
+            <a:off x="6172200" y="3703320"/>
+            <a:ext cx="0" cy="-1554480"/>
+          </a:xfrm>
+          <a:prstGeom prst="line">
+            <a:avLst/>
+          </a:prstGeom>
+          <a:noFill/>
+          <a:ln w="17780">
+            <a:solidFill>
+              <a:srgbClr val="102A43"/>
+            </a:solidFill>
+            <a:prstDash val="solid"/>
+          </a:ln>
+        </p:spPr>
+      </p:sp>
+      <p:sp>
+        <p:nvSpPr>
+          <p:cNvPr id="32" name="Text 30"/>
+          <p:cNvSpPr/>
+          <p:nvPr/>
+        </p:nvSpPr>
+        <p:spPr>
+          <a:xfrm>
+            <a:off x="5806440" y="2020824"/>
+            <a:ext cx="228600" cy="182880"/>
+          </a:xfrm>
+          <a:prstGeom prst="rect">
+            <a:avLst/>
+          </a:prstGeom>
+          <a:noFill/>
+          <a:ln/>
+        </p:spPr>
+        <p:txBody>
+          <a:bodyPr wrap="square" lIns="0" tIns="0" rIns="0" bIns="0" rtlCol="0" anchor="ctr"/>
+          <a:lstStyle/>
+          <a:p>
+            <a:pPr indent="0" marL="0">
+              <a:buNone/>
+            </a:pPr>
+            <a:r>
+              <a:rPr lang="en-US" sz="1200" b="1" dirty="0">
+                <a:solidFill>
+                  <a:srgbClr val="102A43"/>
+                </a:solidFill>
+              </a:rPr>
+              <a:t>P</a:t>
+            </a:r>
+            <a:endParaRPr lang="en-US" sz="1200" dirty="0"/>
+          </a:p>
+        </p:txBody>
+      </p:sp>
+      <p:sp>
+        <p:nvSpPr>
+          <p:cNvPr id="33" name="Text 31"/>
+          <p:cNvSpPr/>
+          <p:nvPr/>
+        </p:nvSpPr>
+        <p:spPr>
+          <a:xfrm>
+            <a:off x="10314432" y="3858768"/>
+            <a:ext cx="228600" cy="182880"/>
+          </a:xfrm>
+          <a:prstGeom prst="rect">
+            <a:avLst/>
+          </a:prstGeom>
+          <a:noFill/>
+          <a:ln/>
+        </p:spPr>
+        <p:txBody>
+          <a:bodyPr wrap="square" lIns="0" tIns="0" rIns="0" bIns="0" rtlCol="0" anchor="ctr"/>
+          <a:lstStyle/>
+          <a:p>
+            <a:pPr indent="0" marL="0">
+              <a:buNone/>
+            </a:pPr>
+            <a:r>
+              <a:rPr lang="en-US" sz="1200" b="1" dirty="0">
+                <a:solidFill>
+                  <a:srgbClr val="102A43"/>
+                </a:solidFill>
+              </a:rPr>
+              <a:t>Q</a:t>
+            </a:r>
+            <a:endParaRPr lang="en-US" sz="1200" dirty="0"/>
+          </a:p>
+        </p:txBody>
+      </p:sp>
+      <p:sp>
+        <p:nvSpPr>
+          <p:cNvPr id="34" name="Shape 32"/>
+          <p:cNvSpPr/>
+          <p:nvPr/>
+        </p:nvSpPr>
+        <p:spPr>
+          <a:xfrm>
+            <a:off x="6565392" y="2441448"/>
+            <a:ext cx="822960" cy="365760"/>
+          </a:xfrm>
+          <a:prstGeom prst="line">
+            <a:avLst/>
+          </a:prstGeom>
+          <a:noFill/>
+          <a:ln w="30480">
+            <a:solidFill>
+              <a:srgbClr val="2F7D4A"/>
+            </a:solidFill>
+            <a:prstDash val="solid"/>
+          </a:ln>
+        </p:spPr>
+      </p:sp>
+      <p:sp>
+        <p:nvSpPr>
+          <p:cNvPr id="35" name="Shape 33"/>
+          <p:cNvSpPr/>
+          <p:nvPr/>
+        </p:nvSpPr>
+        <p:spPr>
+          <a:xfrm>
+            <a:off x="7388352" y="2807208"/>
+            <a:ext cx="822960" cy="365760"/>
+          </a:xfrm>
+          <a:prstGeom prst="line">
+            <a:avLst/>
+          </a:prstGeom>
+          <a:noFill/>
+          <a:ln w="30480">
+            <a:solidFill>
+              <a:srgbClr val="2F7D4A"/>
+            </a:solidFill>
+            <a:prstDash val="solid"/>
+          </a:ln>
+        </p:spPr>
+      </p:sp>
+      <p:sp>
+        <p:nvSpPr>
+          <p:cNvPr id="36" name="Shape 34"/>
+          <p:cNvSpPr/>
+          <p:nvPr/>
+        </p:nvSpPr>
+        <p:spPr>
+          <a:xfrm>
+            <a:off x="8211312" y="3172968"/>
+            <a:ext cx="822960" cy="365760"/>
+          </a:xfrm>
+          <a:prstGeom prst="line">
+            <a:avLst/>
+          </a:prstGeom>
+          <a:noFill/>
+          <a:ln w="30480">
+            <a:solidFill>
+              <a:srgbClr val="2F7D4A"/>
+            </a:solidFill>
+            <a:prstDash val="solid"/>
+          </a:ln>
+        </p:spPr>
+      </p:sp>
+      <p:sp>
+        <p:nvSpPr>
+          <p:cNvPr id="37" name="Shape 35"/>
+          <p:cNvSpPr/>
+          <p:nvPr/>
+        </p:nvSpPr>
+        <p:spPr>
+          <a:xfrm>
+            <a:off x="9034272" y="3538728"/>
+            <a:ext cx="822960" cy="365760"/>
+          </a:xfrm>
+          <a:prstGeom prst="line">
+            <a:avLst/>
+          </a:prstGeom>
+          <a:noFill/>
+          <a:ln w="30480">
+            <a:solidFill>
+              <a:srgbClr val="2F7D4A"/>
+            </a:solidFill>
+            <a:prstDash val="solid"/>
+          </a:ln>
+        </p:spPr>
+      </p:sp>
+      <p:sp>
+        <p:nvSpPr>
+          <p:cNvPr id="38" name="Shape 36"/>
+          <p:cNvSpPr/>
+          <p:nvPr/>
+        </p:nvSpPr>
+        <p:spPr>
+          <a:xfrm>
+            <a:off x="6524244" y="2400300"/>
+            <a:ext cx="82296" cy="82296"/>
+          </a:xfrm>
+          <a:prstGeom prst="ellipse">
+            <a:avLst/>
+          </a:prstGeom>
+          <a:solidFill>
+            <a:srgbClr val="B45309"/>
+          </a:solidFill>
+          <a:ln w="12700">
+            <a:solidFill>
+              <a:srgbClr val="FFFFFF"/>
+            </a:solidFill>
+            <a:prstDash val="solid"/>
+          </a:ln>
+        </p:spPr>
+      </p:sp>
+      <p:sp>
+        <p:nvSpPr>
+          <p:cNvPr id="39" name="Shape 37"/>
+          <p:cNvSpPr/>
+          <p:nvPr/>
+        </p:nvSpPr>
+        <p:spPr>
+          <a:xfrm>
+            <a:off x="7347204" y="2766060"/>
+            <a:ext cx="82296" cy="82296"/>
+          </a:xfrm>
+          <a:prstGeom prst="ellipse">
+            <a:avLst/>
+          </a:prstGeom>
+          <a:solidFill>
+            <a:srgbClr val="B45309"/>
+          </a:solidFill>
+          <a:ln w="12700">
+            <a:solidFill>
+              <a:srgbClr val="FFFFFF"/>
+            </a:solidFill>
+            <a:prstDash val="solid"/>
+          </a:ln>
+        </p:spPr>
+      </p:sp>
+      <p:sp>
+        <p:nvSpPr>
+          <p:cNvPr id="40" name="Shape 38"/>
+          <p:cNvSpPr/>
+          <p:nvPr/>
+        </p:nvSpPr>
+        <p:spPr>
+          <a:xfrm>
+            <a:off x="8170164" y="3131820"/>
+            <a:ext cx="82296" cy="82296"/>
+          </a:xfrm>
+          <a:prstGeom prst="ellipse">
+            <a:avLst/>
+          </a:prstGeom>
+          <a:solidFill>
+            <a:srgbClr val="B45309"/>
+          </a:solidFill>
+          <a:ln w="12700">
+            <a:solidFill>
+              <a:srgbClr val="FFFFFF"/>
+            </a:solidFill>
+            <a:prstDash val="solid"/>
+          </a:ln>
+        </p:spPr>
+      </p:sp>
+      <p:sp>
+        <p:nvSpPr>
+          <p:cNvPr id="41" name="Text 39"/>
+          <p:cNvSpPr/>
+          <p:nvPr/>
+        </p:nvSpPr>
+        <p:spPr>
+          <a:xfrm>
+            <a:off x="8321040" y="2990088"/>
+            <a:ext cx="1097280" cy="182880"/>
+          </a:xfrm>
+          <a:prstGeom prst="rect">
+            <a:avLst/>
+          </a:prstGeom>
+          <a:noFill/>
+          <a:ln/>
+        </p:spPr>
+        <p:txBody>
+          <a:bodyPr wrap="square" lIns="0" tIns="0" rIns="0" bIns="0" rtlCol="0" anchor="ctr"/>
+          <a:lstStyle/>
+          <a:p>
+            <a:pPr indent="0" marL="0">
+              <a:buNone/>
+            </a:pPr>
+            <a:r>
+              <a:rPr lang="en-US" sz="900" dirty="0">
+                <a:solidFill>
+                  <a:srgbClr val="102A43"/>
+                </a:solidFill>
+              </a:rPr>
+              <a:t>(300; 2,00)</a:t>
+            </a:r>
+            <a:endParaRPr lang="en-US" sz="900" dirty="0"/>
+          </a:p>
+        </p:txBody>
+      </p:sp>
+      <p:sp>
+        <p:nvSpPr>
+          <p:cNvPr id="42" name="Shape 40"/>
+          <p:cNvSpPr/>
+          <p:nvPr/>
+        </p:nvSpPr>
+        <p:spPr>
+          <a:xfrm>
+            <a:off x="8993124" y="3497580"/>
+            <a:ext cx="82296" cy="82296"/>
+          </a:xfrm>
+          <a:prstGeom prst="ellipse">
+            <a:avLst/>
+          </a:prstGeom>
+          <a:solidFill>
+            <a:srgbClr val="B45309"/>
+          </a:solidFill>
+          <a:ln w="12700">
+            <a:solidFill>
+              <a:srgbClr val="FFFFFF"/>
+            </a:solidFill>
+            <a:prstDash val="solid"/>
+          </a:ln>
+        </p:spPr>
+      </p:sp>
+      <p:sp>
+        <p:nvSpPr>
+          <p:cNvPr id="43" name="Shape 41"/>
+          <p:cNvSpPr/>
+          <p:nvPr/>
+        </p:nvSpPr>
+        <p:spPr>
+          <a:xfrm>
+            <a:off x="9816084" y="3863340"/>
+            <a:ext cx="82296" cy="82296"/>
+          </a:xfrm>
+          <a:prstGeom prst="ellipse">
+            <a:avLst/>
+          </a:prstGeom>
+          <a:solidFill>
+            <a:srgbClr val="B45309"/>
+          </a:solidFill>
+          <a:ln w="12700">
+            <a:solidFill>
+              <a:srgbClr val="FFFFFF"/>
+            </a:solidFill>
+            <a:prstDash val="solid"/>
+          </a:ln>
+        </p:spPr>
+      </p:sp>
+      <p:sp>
+        <p:nvSpPr>
+          <p:cNvPr id="44" name="Shape 42"/>
+          <p:cNvSpPr/>
+          <p:nvPr/>
+        </p:nvSpPr>
+        <p:spPr>
+          <a:xfrm>
+            <a:off x="777240" y="4480560"/>
+            <a:ext cx="10698480" cy="384048"/>
+          </a:xfrm>
+          <a:prstGeom prst="roundRect">
+            <a:avLst>
+              <a:gd name="adj" fmla="val 14286"/>
+            </a:avLst>
+          </a:prstGeom>
+          <a:solidFill>
+            <a:srgbClr val="ECFEFF"/>
+          </a:solidFill>
+          <a:ln w="12700">
+            <a:solidFill>
+              <a:srgbClr val="BAE6FD"/>
+            </a:solidFill>
+            <a:prstDash val="solid"/>
+          </a:ln>
+        </p:spPr>
+      </p:sp>
+      <p:sp>
+        <p:nvSpPr>
+          <p:cNvPr id="45" name="Text 43"/>
+          <p:cNvSpPr/>
+          <p:nvPr/>
+        </p:nvSpPr>
+        <p:spPr>
+          <a:xfrm>
+            <a:off x="1005840" y="4572000"/>
+            <a:ext cx="10149840" cy="164592"/>
+          </a:xfrm>
+          <a:prstGeom prst="rect">
+            <a:avLst/>
+          </a:prstGeom>
+          <a:noFill/>
+          <a:ln/>
+        </p:spPr>
+        <p:txBody>
+          <a:bodyPr wrap="square" lIns="0" tIns="0" rIns="0" bIns="0" rtlCol="0" anchor="ctr">
+            <a:normAutofit/>
+          </a:bodyPr>
+          <a:lstStyle/>
+          <a:p>
+            <a:pPr indent="0" marL="0">
+              <a:buNone/>
+            </a:pPr>
+            <a:r>
+              <a:rPr lang="en-US" sz="1250" dirty="0">
+                <a:solidFill>
+                  <a:srgbClr val="102A43"/>
+                </a:solidFill>
+              </a:rPr>
+              <a:t>Prijs en aantal verkochte ijsjes staan in verschillende kolommen.</a:t>
+            </a:r>
+            <a:endParaRPr lang="en-US" sz="1250" dirty="0"/>
+          </a:p>
+        </p:txBody>
+      </p:sp>
+      <p:sp>
+        <p:nvSpPr>
+          <p:cNvPr id="46" name="Shape 44"/>
+          <p:cNvSpPr/>
+          <p:nvPr/>
+        </p:nvSpPr>
+        <p:spPr>
+          <a:xfrm>
+            <a:off x="777240" y="4992624"/>
+            <a:ext cx="10698480" cy="384048"/>
+          </a:xfrm>
+          <a:prstGeom prst="roundRect">
+            <a:avLst>
+              <a:gd name="adj" fmla="val 14286"/>
+            </a:avLst>
+          </a:prstGeom>
+          <a:solidFill>
+            <a:srgbClr val="FFFFFF"/>
+          </a:solidFill>
+          <a:ln w="12700">
+            <a:solidFill>
+              <a:srgbClr val="BAE6FD"/>
+            </a:solidFill>
+            <a:prstDash val="solid"/>
+          </a:ln>
+        </p:spPr>
+      </p:sp>
+      <p:sp>
+        <p:nvSpPr>
+          <p:cNvPr id="47" name="Text 45"/>
+          <p:cNvSpPr/>
+          <p:nvPr/>
+        </p:nvSpPr>
+        <p:spPr>
+          <a:xfrm>
+            <a:off x="1005840" y="5084064"/>
+            <a:ext cx="10149840" cy="164592"/>
+          </a:xfrm>
+          <a:prstGeom prst="rect">
+            <a:avLst/>
+          </a:prstGeom>
+          <a:noFill/>
+          <a:ln/>
+        </p:spPr>
+        <p:txBody>
+          <a:bodyPr wrap="square" lIns="0" tIns="0" rIns="0" bIns="0" rtlCol="0" anchor="ctr">
+            <a:normAutofit/>
+          </a:bodyPr>
+          <a:lstStyle/>
+          <a:p>
+            <a:pPr indent="0" marL="0">
+              <a:buNone/>
+            </a:pPr>
+            <a:r>
+              <a:rPr lang="en-US" sz="1250" dirty="0">
+                <a:solidFill>
+                  <a:srgbClr val="102A43"/>
+                </a:solidFill>
+              </a:rPr>
+              <a:t>Een tabel ordent de data; een grafiek maakt het verband zichtbaar.</a:t>
+            </a:r>
+            <a:endParaRPr lang="en-US" sz="1250" dirty="0"/>
+          </a:p>
+        </p:txBody>
+      </p:sp>
+      <p:sp>
+        <p:nvSpPr>
+          <p:cNvPr id="48" name="Shape 46"/>
+          <p:cNvSpPr/>
+          <p:nvPr/>
+        </p:nvSpPr>
+        <p:spPr>
+          <a:xfrm>
+            <a:off x="777240" y="5504688"/>
+            <a:ext cx="10698480" cy="384048"/>
+          </a:xfrm>
+          <a:prstGeom prst="roundRect">
+            <a:avLst>
+              <a:gd name="adj" fmla="val 14286"/>
+            </a:avLst>
+          </a:prstGeom>
+          <a:solidFill>
+            <a:srgbClr val="ECFEFF"/>
+          </a:solidFill>
+          <a:ln w="12700">
+            <a:solidFill>
+              <a:srgbClr val="BAE6FD"/>
+            </a:solidFill>
+            <a:prstDash val="solid"/>
+          </a:ln>
+        </p:spPr>
+      </p:sp>
+      <p:sp>
+        <p:nvSpPr>
+          <p:cNvPr id="49" name="Text 47"/>
+          <p:cNvSpPr/>
+          <p:nvPr/>
+        </p:nvSpPr>
+        <p:spPr>
+          <a:xfrm>
+            <a:off x="1005840" y="5596128"/>
+            <a:ext cx="10149840" cy="164592"/>
+          </a:xfrm>
+          <a:prstGeom prst="rect">
+            <a:avLst/>
+          </a:prstGeom>
+          <a:noFill/>
+          <a:ln/>
+        </p:spPr>
+        <p:txBody>
+          <a:bodyPr wrap="square" lIns="0" tIns="0" rIns="0" bIns="0" rtlCol="0" anchor="ctr">
+            <a:normAutofit/>
+          </a:bodyPr>
+          <a:lstStyle/>
+          <a:p>
+            <a:pPr indent="0" marL="0">
+              <a:buNone/>
+            </a:pPr>
+            <a:r>
+              <a:rPr lang="en-US" sz="1250" dirty="0">
+                <a:solidFill>
+                  <a:srgbClr val="102A43"/>
+                </a:solidFill>
+              </a:rPr>
               <a:t>De eerste vraag is steeds: wat betekenen deze getallen?</a:t>
             </a:r>
-            <a:endParaRPr lang="en-US" sz="1500" dirty="0"/>
+            <a:endParaRPr lang="en-US" sz="1250" dirty="0"/>
           </a:p>
         </p:txBody>
       </p:sp>
@@ -1686,20 +2838,18 @@
         </p:nvSpPr>
         <p:spPr>
           <a:xfrm>
-            <a:off x="914400" y="1965960"/>
-            <a:ext cx="10058400" cy="457200"/>
-          </a:xfrm>
-          <a:prstGeom prst="roundRect">
-            <a:avLst>
-              <a:gd name="adj" fmla="val 16000"/>
-            </a:avLst>
-          </a:prstGeom>
-          <a:solidFill>
-            <a:srgbClr val="ECFEFF"/>
+            <a:off x="2926080" y="1828800"/>
+            <a:ext cx="2926080" cy="388620"/>
+          </a:xfrm>
+          <a:prstGeom prst="rect">
+            <a:avLst/>
+          </a:prstGeom>
+          <a:solidFill>
+            <a:srgbClr val="DDF7EF"/>
           </a:solidFill>
           <a:ln w="12700">
             <a:solidFill>
-              <a:srgbClr val="BAE6FD"/>
+              <a:srgbClr val="CBD5E1"/>
             </a:solidFill>
             <a:prstDash val="solid"/>
           </a:ln>
@@ -1713,8 +2863,8 @@
         </p:nvSpPr>
         <p:spPr>
           <a:xfrm>
-            <a:off x="1143000" y="2084832"/>
-            <a:ext cx="9509760" cy="182880"/>
+            <a:off x="2980944" y="1892808"/>
+            <a:ext cx="2816352" cy="315468"/>
           </a:xfrm>
           <a:prstGeom prst="rect">
             <a:avLst/>
@@ -1732,14 +2882,14 @@
               <a:buNone/>
             </a:pPr>
             <a:r>
-              <a:rPr lang="en-US" sz="1500" dirty="0">
+              <a:rPr lang="en-US" sz="1100" b="1" dirty="0">
                 <a:solidFill>
                   <a:srgbClr val="102A43"/>
                 </a:solidFill>
               </a:rPr>
-              <a:t>Lees de vraag: welke rij, kolom of periode heb je nodig?</a:t>
-            </a:r>
-            <a:endParaRPr lang="en-US" sz="1500" dirty="0"/>
+              <a:t>Prijs</a:t>
+            </a:r>
+            <a:endParaRPr lang="en-US" sz="1100" dirty="0"/>
           </a:p>
         </p:txBody>
       </p:sp>
@@ -1751,20 +2901,18 @@
         </p:nvSpPr>
         <p:spPr>
           <a:xfrm>
-            <a:off x="914400" y="2679192"/>
-            <a:ext cx="10058400" cy="457200"/>
-          </a:xfrm>
-          <a:prstGeom prst="roundRect">
-            <a:avLst>
-              <a:gd name="adj" fmla="val 16000"/>
-            </a:avLst>
-          </a:prstGeom>
-          <a:solidFill>
-            <a:srgbClr val="FFFFFF"/>
+            <a:off x="5852160" y="1828800"/>
+            <a:ext cx="2926080" cy="388620"/>
+          </a:xfrm>
+          <a:prstGeom prst="rect">
+            <a:avLst/>
+          </a:prstGeom>
+          <a:solidFill>
+            <a:srgbClr val="DDF7EF"/>
           </a:solidFill>
           <a:ln w="12700">
             <a:solidFill>
-              <a:srgbClr val="BAE6FD"/>
+              <a:srgbClr val="CBD5E1"/>
             </a:solidFill>
             <a:prstDash val="solid"/>
           </a:ln>
@@ -1778,8 +2926,8 @@
         </p:nvSpPr>
         <p:spPr>
           <a:xfrm>
-            <a:off x="1143000" y="2798064"/>
-            <a:ext cx="9509760" cy="182880"/>
+            <a:off x="5907024" y="1892808"/>
+            <a:ext cx="2816352" cy="315468"/>
           </a:xfrm>
           <a:prstGeom prst="rect">
             <a:avLst/>
@@ -1797,14 +2945,14 @@
               <a:buNone/>
             </a:pPr>
             <a:r>
-              <a:rPr lang="en-US" sz="1500" dirty="0">
+              <a:rPr lang="en-US" sz="1100" b="1" dirty="0">
                 <a:solidFill>
                   <a:srgbClr val="102A43"/>
                 </a:solidFill>
               </a:rPr>
-              <a:t>Controleer tabelkop, rijlabel, kolomlabel en eenheid.</a:t>
-            </a:r>
-            <a:endParaRPr lang="en-US" sz="1500" dirty="0"/>
+              <a:t>Verkoop</a:t>
+            </a:r>
+            <a:endParaRPr lang="en-US" sz="1100" dirty="0"/>
           </a:p>
         </p:txBody>
       </p:sp>
@@ -1816,20 +2964,18 @@
         </p:nvSpPr>
         <p:spPr>
           <a:xfrm>
-            <a:off x="914400" y="3392424"/>
-            <a:ext cx="10058400" cy="457200"/>
-          </a:xfrm>
-          <a:prstGeom prst="roundRect">
-            <a:avLst>
-              <a:gd name="adj" fmla="val 16000"/>
-            </a:avLst>
-          </a:prstGeom>
-          <a:solidFill>
-            <a:srgbClr val="ECFEFF"/>
+            <a:off x="2926080" y="2217420"/>
+            <a:ext cx="2926080" cy="388620"/>
+          </a:xfrm>
+          <a:prstGeom prst="rect">
+            <a:avLst/>
+          </a:prstGeom>
+          <a:solidFill>
+            <a:srgbClr val="FFF4CC"/>
           </a:solidFill>
           <a:ln w="12700">
             <a:solidFill>
-              <a:srgbClr val="BAE6FD"/>
+              <a:srgbClr val="CBD5E1"/>
             </a:solidFill>
             <a:prstDash val="solid"/>
           </a:ln>
@@ -1843,8 +2989,8 @@
         </p:nvSpPr>
         <p:spPr>
           <a:xfrm>
-            <a:off x="1143000" y="3511296"/>
-            <a:ext cx="9509760" cy="182880"/>
+            <a:off x="2980944" y="2281428"/>
+            <a:ext cx="2816352" cy="315468"/>
           </a:xfrm>
           <a:prstGeom prst="rect">
             <a:avLst/>
@@ -1862,14 +3008,776 @@
               <a:buNone/>
             </a:pPr>
             <a:r>
-              <a:rPr lang="en-US" sz="1500" dirty="0">
+              <a:rPr lang="en-US" sz="1000" b="1" dirty="0">
                 <a:solidFill>
                   <a:srgbClr val="102A43"/>
                 </a:solidFill>
               </a:rPr>
+              <a:t>EUR 1,00</a:t>
+            </a:r>
+            <a:endParaRPr lang="en-US" sz="1000" dirty="0"/>
+          </a:p>
+        </p:txBody>
+      </p:sp>
+      <p:sp>
+        <p:nvSpPr>
+          <p:cNvPr id="11" name="Shape 9"/>
+          <p:cNvSpPr/>
+          <p:nvPr/>
+        </p:nvSpPr>
+        <p:spPr>
+          <a:xfrm>
+            <a:off x="5852160" y="2217420"/>
+            <a:ext cx="2926080" cy="388620"/>
+          </a:xfrm>
+          <a:prstGeom prst="rect">
+            <a:avLst/>
+          </a:prstGeom>
+          <a:solidFill>
+            <a:srgbClr val="FFF4CC"/>
+          </a:solidFill>
+          <a:ln w="12700">
+            <a:solidFill>
+              <a:srgbClr val="CBD5E1"/>
+            </a:solidFill>
+            <a:prstDash val="solid"/>
+          </a:ln>
+        </p:spPr>
+      </p:sp>
+      <p:sp>
+        <p:nvSpPr>
+          <p:cNvPr id="12" name="Text 10"/>
+          <p:cNvSpPr/>
+          <p:nvPr/>
+        </p:nvSpPr>
+        <p:spPr>
+          <a:xfrm>
+            <a:off x="5907024" y="2281428"/>
+            <a:ext cx="2816352" cy="315468"/>
+          </a:xfrm>
+          <a:prstGeom prst="rect">
+            <a:avLst/>
+          </a:prstGeom>
+          <a:noFill/>
+          <a:ln/>
+        </p:spPr>
+        <p:txBody>
+          <a:bodyPr wrap="square" lIns="0" tIns="0" rIns="0" bIns="0" rtlCol="0" anchor="ctr">
+            <a:normAutofit/>
+          </a:bodyPr>
+          <a:lstStyle/>
+          <a:p>
+            <a:pPr indent="0" marL="0">
+              <a:buNone/>
+            </a:pPr>
+            <a:r>
+              <a:rPr lang="en-US" sz="1000" b="1" dirty="0">
+                <a:solidFill>
+                  <a:srgbClr val="102A43"/>
+                </a:solidFill>
+              </a:rPr>
+              <a:t>500</a:t>
+            </a:r>
+            <a:endParaRPr lang="en-US" sz="1000" dirty="0"/>
+          </a:p>
+        </p:txBody>
+      </p:sp>
+      <p:sp>
+        <p:nvSpPr>
+          <p:cNvPr id="13" name="Shape 11"/>
+          <p:cNvSpPr/>
+          <p:nvPr/>
+        </p:nvSpPr>
+        <p:spPr>
+          <a:xfrm>
+            <a:off x="2926080" y="2606040"/>
+            <a:ext cx="2926080" cy="388620"/>
+          </a:xfrm>
+          <a:prstGeom prst="rect">
+            <a:avLst/>
+          </a:prstGeom>
+          <a:solidFill>
+            <a:srgbClr val="FFFFFF"/>
+          </a:solidFill>
+          <a:ln w="12700">
+            <a:solidFill>
+              <a:srgbClr val="CBD5E1"/>
+            </a:solidFill>
+            <a:prstDash val="solid"/>
+          </a:ln>
+        </p:spPr>
+      </p:sp>
+      <p:sp>
+        <p:nvSpPr>
+          <p:cNvPr id="14" name="Text 12"/>
+          <p:cNvSpPr/>
+          <p:nvPr/>
+        </p:nvSpPr>
+        <p:spPr>
+          <a:xfrm>
+            <a:off x="2980944" y="2670048"/>
+            <a:ext cx="2816352" cy="315468"/>
+          </a:xfrm>
+          <a:prstGeom prst="rect">
+            <a:avLst/>
+          </a:prstGeom>
+          <a:noFill/>
+          <a:ln/>
+        </p:spPr>
+        <p:txBody>
+          <a:bodyPr wrap="square" lIns="0" tIns="0" rIns="0" bIns="0" rtlCol="0" anchor="ctr">
+            <a:normAutofit/>
+          </a:bodyPr>
+          <a:lstStyle/>
+          <a:p>
+            <a:pPr indent="0" marL="0">
+              <a:buNone/>
+            </a:pPr>
+            <a:r>
+              <a:rPr lang="en-US" sz="1000" dirty="0">
+                <a:solidFill>
+                  <a:srgbClr val="102A43"/>
+                </a:solidFill>
+              </a:rPr>
+              <a:t>EUR 1,50</a:t>
+            </a:r>
+            <a:endParaRPr lang="en-US" sz="1000" dirty="0"/>
+          </a:p>
+        </p:txBody>
+      </p:sp>
+      <p:sp>
+        <p:nvSpPr>
+          <p:cNvPr id="15" name="Shape 13"/>
+          <p:cNvSpPr/>
+          <p:nvPr/>
+        </p:nvSpPr>
+        <p:spPr>
+          <a:xfrm>
+            <a:off x="5852160" y="2606040"/>
+            <a:ext cx="2926080" cy="388620"/>
+          </a:xfrm>
+          <a:prstGeom prst="rect">
+            <a:avLst/>
+          </a:prstGeom>
+          <a:solidFill>
+            <a:srgbClr val="FFFFFF"/>
+          </a:solidFill>
+          <a:ln w="12700">
+            <a:solidFill>
+              <a:srgbClr val="CBD5E1"/>
+            </a:solidFill>
+            <a:prstDash val="solid"/>
+          </a:ln>
+        </p:spPr>
+      </p:sp>
+      <p:sp>
+        <p:nvSpPr>
+          <p:cNvPr id="16" name="Text 14"/>
+          <p:cNvSpPr/>
+          <p:nvPr/>
+        </p:nvSpPr>
+        <p:spPr>
+          <a:xfrm>
+            <a:off x="5907024" y="2670048"/>
+            <a:ext cx="2816352" cy="315468"/>
+          </a:xfrm>
+          <a:prstGeom prst="rect">
+            <a:avLst/>
+          </a:prstGeom>
+          <a:noFill/>
+          <a:ln/>
+        </p:spPr>
+        <p:txBody>
+          <a:bodyPr wrap="square" lIns="0" tIns="0" rIns="0" bIns="0" rtlCol="0" anchor="ctr">
+            <a:normAutofit/>
+          </a:bodyPr>
+          <a:lstStyle/>
+          <a:p>
+            <a:pPr indent="0" marL="0">
+              <a:buNone/>
+            </a:pPr>
+            <a:r>
+              <a:rPr lang="en-US" sz="1000" dirty="0">
+                <a:solidFill>
+                  <a:srgbClr val="102A43"/>
+                </a:solidFill>
+              </a:rPr>
+              <a:t>400</a:t>
+            </a:r>
+            <a:endParaRPr lang="en-US" sz="1000" dirty="0"/>
+          </a:p>
+        </p:txBody>
+      </p:sp>
+      <p:sp>
+        <p:nvSpPr>
+          <p:cNvPr id="17" name="Shape 15"/>
+          <p:cNvSpPr/>
+          <p:nvPr/>
+        </p:nvSpPr>
+        <p:spPr>
+          <a:xfrm>
+            <a:off x="2926080" y="2994660"/>
+            <a:ext cx="2926080" cy="388620"/>
+          </a:xfrm>
+          <a:prstGeom prst="rect">
+            <a:avLst/>
+          </a:prstGeom>
+          <a:solidFill>
+            <a:srgbClr val="FFF4CC"/>
+          </a:solidFill>
+          <a:ln w="12700">
+            <a:solidFill>
+              <a:srgbClr val="CBD5E1"/>
+            </a:solidFill>
+            <a:prstDash val="solid"/>
+          </a:ln>
+        </p:spPr>
+      </p:sp>
+      <p:sp>
+        <p:nvSpPr>
+          <p:cNvPr id="18" name="Text 16"/>
+          <p:cNvSpPr/>
+          <p:nvPr/>
+        </p:nvSpPr>
+        <p:spPr>
+          <a:xfrm>
+            <a:off x="2980944" y="3058668"/>
+            <a:ext cx="2816352" cy="315468"/>
+          </a:xfrm>
+          <a:prstGeom prst="rect">
+            <a:avLst/>
+          </a:prstGeom>
+          <a:noFill/>
+          <a:ln/>
+        </p:spPr>
+        <p:txBody>
+          <a:bodyPr wrap="square" lIns="0" tIns="0" rIns="0" bIns="0" rtlCol="0" anchor="ctr">
+            <a:normAutofit/>
+          </a:bodyPr>
+          <a:lstStyle/>
+          <a:p>
+            <a:pPr indent="0" marL="0">
+              <a:buNone/>
+            </a:pPr>
+            <a:r>
+              <a:rPr lang="en-US" sz="1000" b="1" dirty="0">
+                <a:solidFill>
+                  <a:srgbClr val="102A43"/>
+                </a:solidFill>
+              </a:rPr>
+              <a:t>EUR 2,00</a:t>
+            </a:r>
+            <a:endParaRPr lang="en-US" sz="1000" dirty="0"/>
+          </a:p>
+        </p:txBody>
+      </p:sp>
+      <p:sp>
+        <p:nvSpPr>
+          <p:cNvPr id="19" name="Shape 17"/>
+          <p:cNvSpPr/>
+          <p:nvPr/>
+        </p:nvSpPr>
+        <p:spPr>
+          <a:xfrm>
+            <a:off x="5852160" y="2994660"/>
+            <a:ext cx="2926080" cy="388620"/>
+          </a:xfrm>
+          <a:prstGeom prst="rect">
+            <a:avLst/>
+          </a:prstGeom>
+          <a:solidFill>
+            <a:srgbClr val="FFF4CC"/>
+          </a:solidFill>
+          <a:ln w="12700">
+            <a:solidFill>
+              <a:srgbClr val="CBD5E1"/>
+            </a:solidFill>
+            <a:prstDash val="solid"/>
+          </a:ln>
+        </p:spPr>
+      </p:sp>
+      <p:sp>
+        <p:nvSpPr>
+          <p:cNvPr id="20" name="Text 18"/>
+          <p:cNvSpPr/>
+          <p:nvPr/>
+        </p:nvSpPr>
+        <p:spPr>
+          <a:xfrm>
+            <a:off x="5907024" y="3058668"/>
+            <a:ext cx="2816352" cy="315468"/>
+          </a:xfrm>
+          <a:prstGeom prst="rect">
+            <a:avLst/>
+          </a:prstGeom>
+          <a:noFill/>
+          <a:ln/>
+        </p:spPr>
+        <p:txBody>
+          <a:bodyPr wrap="square" lIns="0" tIns="0" rIns="0" bIns="0" rtlCol="0" anchor="ctr">
+            <a:normAutofit/>
+          </a:bodyPr>
+          <a:lstStyle/>
+          <a:p>
+            <a:pPr indent="0" marL="0">
+              <a:buNone/>
+            </a:pPr>
+            <a:r>
+              <a:rPr lang="en-US" sz="1000" b="1" dirty="0">
+                <a:solidFill>
+                  <a:srgbClr val="102A43"/>
+                </a:solidFill>
+              </a:rPr>
+              <a:t>300</a:t>
+            </a:r>
+            <a:endParaRPr lang="en-US" sz="1000" dirty="0"/>
+          </a:p>
+        </p:txBody>
+      </p:sp>
+      <p:sp>
+        <p:nvSpPr>
+          <p:cNvPr id="21" name="Shape 19"/>
+          <p:cNvSpPr/>
+          <p:nvPr/>
+        </p:nvSpPr>
+        <p:spPr>
+          <a:xfrm>
+            <a:off x="2926080" y="3383280"/>
+            <a:ext cx="2926080" cy="388620"/>
+          </a:xfrm>
+          <a:prstGeom prst="rect">
+            <a:avLst/>
+          </a:prstGeom>
+          <a:solidFill>
+            <a:srgbClr val="FFFFFF"/>
+          </a:solidFill>
+          <a:ln w="12700">
+            <a:solidFill>
+              <a:srgbClr val="CBD5E1"/>
+            </a:solidFill>
+            <a:prstDash val="solid"/>
+          </a:ln>
+        </p:spPr>
+      </p:sp>
+      <p:sp>
+        <p:nvSpPr>
+          <p:cNvPr id="22" name="Text 20"/>
+          <p:cNvSpPr/>
+          <p:nvPr/>
+        </p:nvSpPr>
+        <p:spPr>
+          <a:xfrm>
+            <a:off x="2980944" y="3447288"/>
+            <a:ext cx="2816352" cy="315468"/>
+          </a:xfrm>
+          <a:prstGeom prst="rect">
+            <a:avLst/>
+          </a:prstGeom>
+          <a:noFill/>
+          <a:ln/>
+        </p:spPr>
+        <p:txBody>
+          <a:bodyPr wrap="square" lIns="0" tIns="0" rIns="0" bIns="0" rtlCol="0" anchor="ctr">
+            <a:normAutofit/>
+          </a:bodyPr>
+          <a:lstStyle/>
+          <a:p>
+            <a:pPr indent="0" marL="0">
+              <a:buNone/>
+            </a:pPr>
+            <a:r>
+              <a:rPr lang="en-US" sz="1000" dirty="0">
+                <a:solidFill>
+                  <a:srgbClr val="102A43"/>
+                </a:solidFill>
+              </a:rPr>
+              <a:t>EUR 2,50</a:t>
+            </a:r>
+            <a:endParaRPr lang="en-US" sz="1000" dirty="0"/>
+          </a:p>
+        </p:txBody>
+      </p:sp>
+      <p:sp>
+        <p:nvSpPr>
+          <p:cNvPr id="23" name="Shape 21"/>
+          <p:cNvSpPr/>
+          <p:nvPr/>
+        </p:nvSpPr>
+        <p:spPr>
+          <a:xfrm>
+            <a:off x="5852160" y="3383280"/>
+            <a:ext cx="2926080" cy="388620"/>
+          </a:xfrm>
+          <a:prstGeom prst="rect">
+            <a:avLst/>
+          </a:prstGeom>
+          <a:solidFill>
+            <a:srgbClr val="FFFFFF"/>
+          </a:solidFill>
+          <a:ln w="12700">
+            <a:solidFill>
+              <a:srgbClr val="CBD5E1"/>
+            </a:solidFill>
+            <a:prstDash val="solid"/>
+          </a:ln>
+        </p:spPr>
+      </p:sp>
+      <p:sp>
+        <p:nvSpPr>
+          <p:cNvPr id="24" name="Text 22"/>
+          <p:cNvSpPr/>
+          <p:nvPr/>
+        </p:nvSpPr>
+        <p:spPr>
+          <a:xfrm>
+            <a:off x="5907024" y="3447288"/>
+            <a:ext cx="2816352" cy="315468"/>
+          </a:xfrm>
+          <a:prstGeom prst="rect">
+            <a:avLst/>
+          </a:prstGeom>
+          <a:noFill/>
+          <a:ln/>
+        </p:spPr>
+        <p:txBody>
+          <a:bodyPr wrap="square" lIns="0" tIns="0" rIns="0" bIns="0" rtlCol="0" anchor="ctr">
+            <a:normAutofit/>
+          </a:bodyPr>
+          <a:lstStyle/>
+          <a:p>
+            <a:pPr indent="0" marL="0">
+              <a:buNone/>
+            </a:pPr>
+            <a:r>
+              <a:rPr lang="en-US" sz="1000" dirty="0">
+                <a:solidFill>
+                  <a:srgbClr val="102A43"/>
+                </a:solidFill>
+              </a:rPr>
+              <a:t>200</a:t>
+            </a:r>
+            <a:endParaRPr lang="en-US" sz="1000" dirty="0"/>
+          </a:p>
+        </p:txBody>
+      </p:sp>
+      <p:sp>
+        <p:nvSpPr>
+          <p:cNvPr id="25" name="Shape 23"/>
+          <p:cNvSpPr/>
+          <p:nvPr/>
+        </p:nvSpPr>
+        <p:spPr>
+          <a:xfrm>
+            <a:off x="2926080" y="3771900"/>
+            <a:ext cx="2926080" cy="388620"/>
+          </a:xfrm>
+          <a:prstGeom prst="rect">
+            <a:avLst/>
+          </a:prstGeom>
+          <a:solidFill>
+            <a:srgbClr val="FFFFFF"/>
+          </a:solidFill>
+          <a:ln w="12700">
+            <a:solidFill>
+              <a:srgbClr val="CBD5E1"/>
+            </a:solidFill>
+            <a:prstDash val="solid"/>
+          </a:ln>
+        </p:spPr>
+      </p:sp>
+      <p:sp>
+        <p:nvSpPr>
+          <p:cNvPr id="26" name="Text 24"/>
+          <p:cNvSpPr/>
+          <p:nvPr/>
+        </p:nvSpPr>
+        <p:spPr>
+          <a:xfrm>
+            <a:off x="2980944" y="3835908"/>
+            <a:ext cx="2816352" cy="315468"/>
+          </a:xfrm>
+          <a:prstGeom prst="rect">
+            <a:avLst/>
+          </a:prstGeom>
+          <a:noFill/>
+          <a:ln/>
+        </p:spPr>
+        <p:txBody>
+          <a:bodyPr wrap="square" lIns="0" tIns="0" rIns="0" bIns="0" rtlCol="0" anchor="ctr">
+            <a:normAutofit/>
+          </a:bodyPr>
+          <a:lstStyle/>
+          <a:p>
+            <a:pPr indent="0" marL="0">
+              <a:buNone/>
+            </a:pPr>
+            <a:r>
+              <a:rPr lang="en-US" sz="1000" dirty="0">
+                <a:solidFill>
+                  <a:srgbClr val="102A43"/>
+                </a:solidFill>
+              </a:rPr>
+              <a:t>EUR 3,00</a:t>
+            </a:r>
+            <a:endParaRPr lang="en-US" sz="1000" dirty="0"/>
+          </a:p>
+        </p:txBody>
+      </p:sp>
+      <p:sp>
+        <p:nvSpPr>
+          <p:cNvPr id="27" name="Shape 25"/>
+          <p:cNvSpPr/>
+          <p:nvPr/>
+        </p:nvSpPr>
+        <p:spPr>
+          <a:xfrm>
+            <a:off x="5852160" y="3771900"/>
+            <a:ext cx="2926080" cy="388620"/>
+          </a:xfrm>
+          <a:prstGeom prst="rect">
+            <a:avLst/>
+          </a:prstGeom>
+          <a:solidFill>
+            <a:srgbClr val="FFFFFF"/>
+          </a:solidFill>
+          <a:ln w="12700">
+            <a:solidFill>
+              <a:srgbClr val="CBD5E1"/>
+            </a:solidFill>
+            <a:prstDash val="solid"/>
+          </a:ln>
+        </p:spPr>
+      </p:sp>
+      <p:sp>
+        <p:nvSpPr>
+          <p:cNvPr id="28" name="Text 26"/>
+          <p:cNvSpPr/>
+          <p:nvPr/>
+        </p:nvSpPr>
+        <p:spPr>
+          <a:xfrm>
+            <a:off x="5907024" y="3835908"/>
+            <a:ext cx="2816352" cy="315468"/>
+          </a:xfrm>
+          <a:prstGeom prst="rect">
+            <a:avLst/>
+          </a:prstGeom>
+          <a:noFill/>
+          <a:ln/>
+        </p:spPr>
+        <p:txBody>
+          <a:bodyPr wrap="square" lIns="0" tIns="0" rIns="0" bIns="0" rtlCol="0" anchor="ctr">
+            <a:normAutofit/>
+          </a:bodyPr>
+          <a:lstStyle/>
+          <a:p>
+            <a:pPr indent="0" marL="0">
+              <a:buNone/>
+            </a:pPr>
+            <a:r>
+              <a:rPr lang="en-US" sz="1000" dirty="0">
+                <a:solidFill>
+                  <a:srgbClr val="102A43"/>
+                </a:solidFill>
+              </a:rPr>
+              <a:t>100</a:t>
+            </a:r>
+            <a:endParaRPr lang="en-US" sz="1000" dirty="0"/>
+          </a:p>
+        </p:txBody>
+      </p:sp>
+      <p:sp>
+        <p:nvSpPr>
+          <p:cNvPr id="29" name="Shape 27"/>
+          <p:cNvSpPr/>
+          <p:nvPr/>
+        </p:nvSpPr>
+        <p:spPr>
+          <a:xfrm>
+            <a:off x="777240" y="4480560"/>
+            <a:ext cx="10698480" cy="384048"/>
+          </a:xfrm>
+          <a:prstGeom prst="roundRect">
+            <a:avLst>
+              <a:gd name="adj" fmla="val 14286"/>
+            </a:avLst>
+          </a:prstGeom>
+          <a:solidFill>
+            <a:srgbClr val="ECFEFF"/>
+          </a:solidFill>
+          <a:ln w="12700">
+            <a:solidFill>
+              <a:srgbClr val="BAE6FD"/>
+            </a:solidFill>
+            <a:prstDash val="solid"/>
+          </a:ln>
+        </p:spPr>
+      </p:sp>
+      <p:sp>
+        <p:nvSpPr>
+          <p:cNvPr id="30" name="Text 28"/>
+          <p:cNvSpPr/>
+          <p:nvPr/>
+        </p:nvSpPr>
+        <p:spPr>
+          <a:xfrm>
+            <a:off x="1005840" y="4572000"/>
+            <a:ext cx="10149840" cy="164592"/>
+          </a:xfrm>
+          <a:prstGeom prst="rect">
+            <a:avLst/>
+          </a:prstGeom>
+          <a:noFill/>
+          <a:ln/>
+        </p:spPr>
+        <p:txBody>
+          <a:bodyPr wrap="square" lIns="0" tIns="0" rIns="0" bIns="0" rtlCol="0" anchor="ctr">
+            <a:normAutofit/>
+          </a:bodyPr>
+          <a:lstStyle/>
+          <a:p>
+            <a:pPr indent="0" marL="0">
+              <a:buNone/>
+            </a:pPr>
+            <a:r>
+              <a:rPr lang="en-US" sz="1250" dirty="0">
+                <a:solidFill>
+                  <a:srgbClr val="102A43"/>
+                </a:solidFill>
+              </a:rPr>
+              <a:t>Lees de vraag: welke rij, kolom of periode heb je nodig?</a:t>
+            </a:r>
+            <a:endParaRPr lang="en-US" sz="1250" dirty="0"/>
+          </a:p>
+        </p:txBody>
+      </p:sp>
+      <p:sp>
+        <p:nvSpPr>
+          <p:cNvPr id="31" name="Shape 29"/>
+          <p:cNvSpPr/>
+          <p:nvPr/>
+        </p:nvSpPr>
+        <p:spPr>
+          <a:xfrm>
+            <a:off x="777240" y="4992624"/>
+            <a:ext cx="10698480" cy="384048"/>
+          </a:xfrm>
+          <a:prstGeom prst="roundRect">
+            <a:avLst>
+              <a:gd name="adj" fmla="val 14286"/>
+            </a:avLst>
+          </a:prstGeom>
+          <a:solidFill>
+            <a:srgbClr val="FFFFFF"/>
+          </a:solidFill>
+          <a:ln w="12700">
+            <a:solidFill>
+              <a:srgbClr val="BAE6FD"/>
+            </a:solidFill>
+            <a:prstDash val="solid"/>
+          </a:ln>
+        </p:spPr>
+      </p:sp>
+      <p:sp>
+        <p:nvSpPr>
+          <p:cNvPr id="32" name="Text 30"/>
+          <p:cNvSpPr/>
+          <p:nvPr/>
+        </p:nvSpPr>
+        <p:spPr>
+          <a:xfrm>
+            <a:off x="1005840" y="5084064"/>
+            <a:ext cx="10149840" cy="164592"/>
+          </a:xfrm>
+          <a:prstGeom prst="rect">
+            <a:avLst/>
+          </a:prstGeom>
+          <a:noFill/>
+          <a:ln/>
+        </p:spPr>
+        <p:txBody>
+          <a:bodyPr wrap="square" lIns="0" tIns="0" rIns="0" bIns="0" rtlCol="0" anchor="ctr">
+            <a:normAutofit/>
+          </a:bodyPr>
+          <a:lstStyle/>
+          <a:p>
+            <a:pPr indent="0" marL="0">
+              <a:buNone/>
+            </a:pPr>
+            <a:r>
+              <a:rPr lang="en-US" sz="1250" dirty="0">
+                <a:solidFill>
+                  <a:srgbClr val="102A43"/>
+                </a:solidFill>
+              </a:rPr>
+              <a:t>Controleer tabelkop, rijlabel, kolomlabel en eenheid.</a:t>
+            </a:r>
+            <a:endParaRPr lang="en-US" sz="1250" dirty="0"/>
+          </a:p>
+        </p:txBody>
+      </p:sp>
+      <p:sp>
+        <p:nvSpPr>
+          <p:cNvPr id="33" name="Shape 31"/>
+          <p:cNvSpPr/>
+          <p:nvPr/>
+        </p:nvSpPr>
+        <p:spPr>
+          <a:xfrm>
+            <a:off x="777240" y="5504688"/>
+            <a:ext cx="10698480" cy="384048"/>
+          </a:xfrm>
+          <a:prstGeom prst="roundRect">
+            <a:avLst>
+              <a:gd name="adj" fmla="val 14286"/>
+            </a:avLst>
+          </a:prstGeom>
+          <a:solidFill>
+            <a:srgbClr val="ECFEFF"/>
+          </a:solidFill>
+          <a:ln w="12700">
+            <a:solidFill>
+              <a:srgbClr val="BAE6FD"/>
+            </a:solidFill>
+            <a:prstDash val="solid"/>
+          </a:ln>
+        </p:spPr>
+      </p:sp>
+      <p:sp>
+        <p:nvSpPr>
+          <p:cNvPr id="34" name="Text 32"/>
+          <p:cNvSpPr/>
+          <p:nvPr/>
+        </p:nvSpPr>
+        <p:spPr>
+          <a:xfrm>
+            <a:off x="1005840" y="5596128"/>
+            <a:ext cx="10149840" cy="164592"/>
+          </a:xfrm>
+          <a:prstGeom prst="rect">
+            <a:avLst/>
+          </a:prstGeom>
+          <a:noFill/>
+          <a:ln/>
+        </p:spPr>
+        <p:txBody>
+          <a:bodyPr wrap="square" lIns="0" tIns="0" rIns="0" bIns="0" rtlCol="0" anchor="ctr">
+            <a:normAutofit/>
+          </a:bodyPr>
+          <a:lstStyle/>
+          <a:p>
+            <a:pPr indent="0" marL="0">
+              <a:buNone/>
+            </a:pPr>
+            <a:r>
+              <a:rPr lang="en-US" sz="1250" dirty="0">
+                <a:solidFill>
+                  <a:srgbClr val="102A43"/>
+                </a:solidFill>
+              </a:rPr>
               <a:t>Label je waarden: oud = 500 ijsjes, nieuw = 300 ijsjes.</a:t>
             </a:r>
-            <a:endParaRPr lang="en-US" sz="1500" dirty="0"/>
+            <a:endParaRPr lang="en-US" sz="1250" dirty="0"/>
           </a:p>
         </p:txBody>
       </p:sp>
@@ -2023,12 +3931,408 @@
         </p:nvSpPr>
         <p:spPr>
           <a:xfrm>
-            <a:off x="914400" y="1965960"/>
-            <a:ext cx="10058400" cy="457200"/>
+            <a:off x="3108960" y="1828800"/>
+            <a:ext cx="5669280" cy="2377440"/>
+          </a:xfrm>
+          <a:prstGeom prst="rect">
+            <a:avLst/>
+          </a:prstGeom>
+          <a:solidFill>
+            <a:srgbClr val="FFFFFF"/>
+          </a:solidFill>
+          <a:ln w="12700">
+            <a:solidFill>
+              <a:srgbClr val="CBD5E1"/>
+            </a:solidFill>
+            <a:prstDash val="solid"/>
+          </a:ln>
+        </p:spPr>
+      </p:sp>
+      <p:sp>
+        <p:nvSpPr>
+          <p:cNvPr id="6" name="Shape 4"/>
+          <p:cNvSpPr/>
+          <p:nvPr/>
+        </p:nvSpPr>
+        <p:spPr>
+          <a:xfrm>
+            <a:off x="3611880" y="3794760"/>
+            <a:ext cx="4892040" cy="0"/>
+          </a:xfrm>
+          <a:prstGeom prst="line">
+            <a:avLst/>
+          </a:prstGeom>
+          <a:noFill/>
+          <a:ln w="17780">
+            <a:solidFill>
+              <a:srgbClr val="102A43"/>
+            </a:solidFill>
+            <a:prstDash val="solid"/>
+          </a:ln>
+        </p:spPr>
+      </p:sp>
+      <p:sp>
+        <p:nvSpPr>
+          <p:cNvPr id="7" name="Shape 5"/>
+          <p:cNvSpPr/>
+          <p:nvPr/>
+        </p:nvSpPr>
+        <p:spPr>
+          <a:xfrm>
+            <a:off x="3611880" y="3794760"/>
+            <a:ext cx="0" cy="-1691640"/>
+          </a:xfrm>
+          <a:prstGeom prst="line">
+            <a:avLst/>
+          </a:prstGeom>
+          <a:noFill/>
+          <a:ln w="17780">
+            <a:solidFill>
+              <a:srgbClr val="102A43"/>
+            </a:solidFill>
+            <a:prstDash val="solid"/>
+          </a:ln>
+        </p:spPr>
+      </p:sp>
+      <p:sp>
+        <p:nvSpPr>
+          <p:cNvPr id="8" name="Text 6"/>
+          <p:cNvSpPr/>
+          <p:nvPr/>
+        </p:nvSpPr>
+        <p:spPr>
+          <a:xfrm>
+            <a:off x="3246120" y="1975104"/>
+            <a:ext cx="228600" cy="182880"/>
+          </a:xfrm>
+          <a:prstGeom prst="rect">
+            <a:avLst/>
+          </a:prstGeom>
+          <a:noFill/>
+          <a:ln/>
+        </p:spPr>
+        <p:txBody>
+          <a:bodyPr wrap="square" lIns="0" tIns="0" rIns="0" bIns="0" rtlCol="0" anchor="ctr"/>
+          <a:lstStyle/>
+          <a:p>
+            <a:pPr indent="0" marL="0">
+              <a:buNone/>
+            </a:pPr>
+            <a:r>
+              <a:rPr lang="en-US" sz="1200" b="1" dirty="0">
+                <a:solidFill>
+                  <a:srgbClr val="102A43"/>
+                </a:solidFill>
+              </a:rPr>
+              <a:t>P</a:t>
+            </a:r>
+            <a:endParaRPr lang="en-US" sz="1200" dirty="0"/>
+          </a:p>
+        </p:txBody>
+      </p:sp>
+      <p:sp>
+        <p:nvSpPr>
+          <p:cNvPr id="9" name="Text 7"/>
+          <p:cNvSpPr/>
+          <p:nvPr/>
+        </p:nvSpPr>
+        <p:spPr>
+          <a:xfrm>
+            <a:off x="8394192" y="3950208"/>
+            <a:ext cx="228600" cy="182880"/>
+          </a:xfrm>
+          <a:prstGeom prst="rect">
+            <a:avLst/>
+          </a:prstGeom>
+          <a:noFill/>
+          <a:ln/>
+        </p:spPr>
+        <p:txBody>
+          <a:bodyPr wrap="square" lIns="0" tIns="0" rIns="0" bIns="0" rtlCol="0" anchor="ctr"/>
+          <a:lstStyle/>
+          <a:p>
+            <a:pPr indent="0" marL="0">
+              <a:buNone/>
+            </a:pPr>
+            <a:r>
+              <a:rPr lang="en-US" sz="1200" b="1" dirty="0">
+                <a:solidFill>
+                  <a:srgbClr val="102A43"/>
+                </a:solidFill>
+              </a:rPr>
+              <a:t>Q</a:t>
+            </a:r>
+            <a:endParaRPr lang="en-US" sz="1200" dirty="0"/>
+          </a:p>
+        </p:txBody>
+      </p:sp>
+      <p:sp>
+        <p:nvSpPr>
+          <p:cNvPr id="10" name="Shape 8"/>
+          <p:cNvSpPr/>
+          <p:nvPr/>
+        </p:nvSpPr>
+        <p:spPr>
+          <a:xfrm>
+            <a:off x="4005072" y="2395728"/>
+            <a:ext cx="822960" cy="365760"/>
+          </a:xfrm>
+          <a:prstGeom prst="line">
+            <a:avLst/>
+          </a:prstGeom>
+          <a:noFill/>
+          <a:ln w="30480">
+            <a:solidFill>
+              <a:srgbClr val="2F7D4A"/>
+            </a:solidFill>
+            <a:prstDash val="solid"/>
+          </a:ln>
+        </p:spPr>
+      </p:sp>
+      <p:sp>
+        <p:nvSpPr>
+          <p:cNvPr id="11" name="Shape 9"/>
+          <p:cNvSpPr/>
+          <p:nvPr/>
+        </p:nvSpPr>
+        <p:spPr>
+          <a:xfrm>
+            <a:off x="4828032" y="2761488"/>
+            <a:ext cx="822960" cy="365760"/>
+          </a:xfrm>
+          <a:prstGeom prst="line">
+            <a:avLst/>
+          </a:prstGeom>
+          <a:noFill/>
+          <a:ln w="30480">
+            <a:solidFill>
+              <a:srgbClr val="2F7D4A"/>
+            </a:solidFill>
+            <a:prstDash val="solid"/>
+          </a:ln>
+        </p:spPr>
+      </p:sp>
+      <p:sp>
+        <p:nvSpPr>
+          <p:cNvPr id="12" name="Shape 10"/>
+          <p:cNvSpPr/>
+          <p:nvPr/>
+        </p:nvSpPr>
+        <p:spPr>
+          <a:xfrm>
+            <a:off x="5650992" y="3127248"/>
+            <a:ext cx="822960" cy="365760"/>
+          </a:xfrm>
+          <a:prstGeom prst="line">
+            <a:avLst/>
+          </a:prstGeom>
+          <a:noFill/>
+          <a:ln w="30480">
+            <a:solidFill>
+              <a:srgbClr val="2F7D4A"/>
+            </a:solidFill>
+            <a:prstDash val="solid"/>
+          </a:ln>
+        </p:spPr>
+      </p:sp>
+      <p:sp>
+        <p:nvSpPr>
+          <p:cNvPr id="13" name="Shape 11"/>
+          <p:cNvSpPr/>
+          <p:nvPr/>
+        </p:nvSpPr>
+        <p:spPr>
+          <a:xfrm>
+            <a:off x="6473952" y="3493008"/>
+            <a:ext cx="822960" cy="365760"/>
+          </a:xfrm>
+          <a:prstGeom prst="line">
+            <a:avLst/>
+          </a:prstGeom>
+          <a:noFill/>
+          <a:ln w="30480">
+            <a:solidFill>
+              <a:srgbClr val="2F7D4A"/>
+            </a:solidFill>
+            <a:prstDash val="solid"/>
+          </a:ln>
+        </p:spPr>
+      </p:sp>
+      <p:sp>
+        <p:nvSpPr>
+          <p:cNvPr id="14" name="Shape 12"/>
+          <p:cNvSpPr/>
+          <p:nvPr/>
+        </p:nvSpPr>
+        <p:spPr>
+          <a:xfrm>
+            <a:off x="3963924" y="2354580"/>
+            <a:ext cx="82296" cy="82296"/>
+          </a:xfrm>
+          <a:prstGeom prst="ellipse">
+            <a:avLst/>
+          </a:prstGeom>
+          <a:solidFill>
+            <a:srgbClr val="B45309"/>
+          </a:solidFill>
+          <a:ln w="12700">
+            <a:solidFill>
+              <a:srgbClr val="FFFFFF"/>
+            </a:solidFill>
+            <a:prstDash val="solid"/>
+          </a:ln>
+        </p:spPr>
+      </p:sp>
+      <p:sp>
+        <p:nvSpPr>
+          <p:cNvPr id="15" name="Shape 13"/>
+          <p:cNvSpPr/>
+          <p:nvPr/>
+        </p:nvSpPr>
+        <p:spPr>
+          <a:xfrm>
+            <a:off x="4786884" y="2720340"/>
+            <a:ext cx="82296" cy="82296"/>
+          </a:xfrm>
+          <a:prstGeom prst="ellipse">
+            <a:avLst/>
+          </a:prstGeom>
+          <a:solidFill>
+            <a:srgbClr val="B45309"/>
+          </a:solidFill>
+          <a:ln w="12700">
+            <a:solidFill>
+              <a:srgbClr val="FFFFFF"/>
+            </a:solidFill>
+            <a:prstDash val="solid"/>
+          </a:ln>
+        </p:spPr>
+      </p:sp>
+      <p:sp>
+        <p:nvSpPr>
+          <p:cNvPr id="16" name="Shape 14"/>
+          <p:cNvSpPr/>
+          <p:nvPr/>
+        </p:nvSpPr>
+        <p:spPr>
+          <a:xfrm>
+            <a:off x="5609844" y="3086100"/>
+            <a:ext cx="82296" cy="82296"/>
+          </a:xfrm>
+          <a:prstGeom prst="ellipse">
+            <a:avLst/>
+          </a:prstGeom>
+          <a:solidFill>
+            <a:srgbClr val="B45309"/>
+          </a:solidFill>
+          <a:ln w="12700">
+            <a:solidFill>
+              <a:srgbClr val="FFFFFF"/>
+            </a:solidFill>
+            <a:prstDash val="solid"/>
+          </a:ln>
+        </p:spPr>
+      </p:sp>
+      <p:sp>
+        <p:nvSpPr>
+          <p:cNvPr id="17" name="Text 15"/>
+          <p:cNvSpPr/>
+          <p:nvPr/>
+        </p:nvSpPr>
+        <p:spPr>
+          <a:xfrm>
+            <a:off x="5760720" y="2944368"/>
+            <a:ext cx="1097280" cy="182880"/>
+          </a:xfrm>
+          <a:prstGeom prst="rect">
+            <a:avLst/>
+          </a:prstGeom>
+          <a:noFill/>
+          <a:ln/>
+        </p:spPr>
+        <p:txBody>
+          <a:bodyPr wrap="square" lIns="0" tIns="0" rIns="0" bIns="0" rtlCol="0" anchor="ctr"/>
+          <a:lstStyle/>
+          <a:p>
+            <a:pPr indent="0" marL="0">
+              <a:buNone/>
+            </a:pPr>
+            <a:r>
+              <a:rPr lang="en-US" sz="900" dirty="0">
+                <a:solidFill>
+                  <a:srgbClr val="102A43"/>
+                </a:solidFill>
+              </a:rPr>
+              <a:t>(300; 2,00)</a:t>
+            </a:r>
+            <a:endParaRPr lang="en-US" sz="900" dirty="0"/>
+          </a:p>
+        </p:txBody>
+      </p:sp>
+      <p:sp>
+        <p:nvSpPr>
+          <p:cNvPr id="18" name="Shape 16"/>
+          <p:cNvSpPr/>
+          <p:nvPr/>
+        </p:nvSpPr>
+        <p:spPr>
+          <a:xfrm>
+            <a:off x="6432804" y="3451860"/>
+            <a:ext cx="82296" cy="82296"/>
+          </a:xfrm>
+          <a:prstGeom prst="ellipse">
+            <a:avLst/>
+          </a:prstGeom>
+          <a:solidFill>
+            <a:srgbClr val="B45309"/>
+          </a:solidFill>
+          <a:ln w="12700">
+            <a:solidFill>
+              <a:srgbClr val="FFFFFF"/>
+            </a:solidFill>
+            <a:prstDash val="solid"/>
+          </a:ln>
+        </p:spPr>
+      </p:sp>
+      <p:sp>
+        <p:nvSpPr>
+          <p:cNvPr id="19" name="Shape 17"/>
+          <p:cNvSpPr/>
+          <p:nvPr/>
+        </p:nvSpPr>
+        <p:spPr>
+          <a:xfrm>
+            <a:off x="7255764" y="3817620"/>
+            <a:ext cx="82296" cy="82296"/>
+          </a:xfrm>
+          <a:prstGeom prst="ellipse">
+            <a:avLst/>
+          </a:prstGeom>
+          <a:solidFill>
+            <a:srgbClr val="B45309"/>
+          </a:solidFill>
+          <a:ln w="12700">
+            <a:solidFill>
+              <a:srgbClr val="FFFFFF"/>
+            </a:solidFill>
+            <a:prstDash val="solid"/>
+          </a:ln>
+        </p:spPr>
+      </p:sp>
+      <p:sp>
+        <p:nvSpPr>
+          <p:cNvPr id="20" name="Shape 18"/>
+          <p:cNvSpPr/>
+          <p:nvPr/>
+        </p:nvSpPr>
+        <p:spPr>
+          <a:xfrm>
+            <a:off x="777240" y="4480560"/>
+            <a:ext cx="10698480" cy="384048"/>
           </a:xfrm>
           <a:prstGeom prst="roundRect">
             <a:avLst>
-              <a:gd name="adj" fmla="val 16000"/>
+              <a:gd name="adj" fmla="val 14286"/>
             </a:avLst>
           </a:prstGeom>
           <a:solidFill>
@@ -2044,14 +4348,14 @@
       </p:sp>
       <p:sp>
         <p:nvSpPr>
-          <p:cNvPr id="6" name="Text 4"/>
-          <p:cNvSpPr/>
-          <p:nvPr/>
-        </p:nvSpPr>
-        <p:spPr>
-          <a:xfrm>
-            <a:off x="1143000" y="2084832"/>
-            <a:ext cx="9509760" cy="182880"/>
+          <p:cNvPr id="21" name="Text 19"/>
+          <p:cNvSpPr/>
+          <p:nvPr/>
+        </p:nvSpPr>
+        <p:spPr>
+          <a:xfrm>
+            <a:off x="1005840" y="4572000"/>
+            <a:ext cx="10149840" cy="164592"/>
           </a:xfrm>
           <a:prstGeom prst="rect">
             <a:avLst/>
@@ -2069,31 +4373,31 @@
               <a:buNone/>
             </a:pPr>
             <a:r>
-              <a:rPr lang="en-US" sz="1500" dirty="0">
+              <a:rPr lang="en-US" sz="1250" dirty="0">
                 <a:solidFill>
                   <a:srgbClr val="102A43"/>
                 </a:solidFill>
               </a:rPr>
               <a:t>P staat op de verticale as.</a:t>
             </a:r>
-            <a:endParaRPr lang="en-US" sz="1500" dirty="0"/>
-          </a:p>
-        </p:txBody>
-      </p:sp>
-      <p:sp>
-        <p:nvSpPr>
-          <p:cNvPr id="7" name="Shape 5"/>
-          <p:cNvSpPr/>
-          <p:nvPr/>
-        </p:nvSpPr>
-        <p:spPr>
-          <a:xfrm>
-            <a:off x="914400" y="2679192"/>
-            <a:ext cx="10058400" cy="457200"/>
+            <a:endParaRPr lang="en-US" sz="1250" dirty="0"/>
+          </a:p>
+        </p:txBody>
+      </p:sp>
+      <p:sp>
+        <p:nvSpPr>
+          <p:cNvPr id="22" name="Shape 20"/>
+          <p:cNvSpPr/>
+          <p:nvPr/>
+        </p:nvSpPr>
+        <p:spPr>
+          <a:xfrm>
+            <a:off x="777240" y="4992624"/>
+            <a:ext cx="10698480" cy="384048"/>
           </a:xfrm>
           <a:prstGeom prst="roundRect">
             <a:avLst>
-              <a:gd name="adj" fmla="val 16000"/>
+              <a:gd name="adj" fmla="val 14286"/>
             </a:avLst>
           </a:prstGeom>
           <a:solidFill>
@@ -2109,14 +4413,14 @@
       </p:sp>
       <p:sp>
         <p:nvSpPr>
-          <p:cNvPr id="8" name="Text 6"/>
-          <p:cNvSpPr/>
-          <p:nvPr/>
-        </p:nvSpPr>
-        <p:spPr>
-          <a:xfrm>
-            <a:off x="1143000" y="2798064"/>
-            <a:ext cx="9509760" cy="182880"/>
+          <p:cNvPr id="23" name="Text 21"/>
+          <p:cNvSpPr/>
+          <p:nvPr/>
+        </p:nvSpPr>
+        <p:spPr>
+          <a:xfrm>
+            <a:off x="1005840" y="5084064"/>
+            <a:ext cx="10149840" cy="164592"/>
           </a:xfrm>
           <a:prstGeom prst="rect">
             <a:avLst/>
@@ -2134,31 +4438,31 @@
               <a:buNone/>
             </a:pPr>
             <a:r>
-              <a:rPr lang="en-US" sz="1500" dirty="0">
+              <a:rPr lang="en-US" sz="1250" dirty="0">
                 <a:solidFill>
                   <a:srgbClr val="102A43"/>
                 </a:solidFill>
               </a:rPr>
               <a:t>Q staat op de horizontale as.</a:t>
             </a:r>
-            <a:endParaRPr lang="en-US" sz="1500" dirty="0"/>
-          </a:p>
-        </p:txBody>
-      </p:sp>
-      <p:sp>
-        <p:nvSpPr>
-          <p:cNvPr id="9" name="Shape 7"/>
-          <p:cNvSpPr/>
-          <p:nvPr/>
-        </p:nvSpPr>
-        <p:spPr>
-          <a:xfrm>
-            <a:off x="914400" y="3392424"/>
-            <a:ext cx="10058400" cy="457200"/>
+            <a:endParaRPr lang="en-US" sz="1250" dirty="0"/>
+          </a:p>
+        </p:txBody>
+      </p:sp>
+      <p:sp>
+        <p:nvSpPr>
+          <p:cNvPr id="24" name="Shape 22"/>
+          <p:cNvSpPr/>
+          <p:nvPr/>
+        </p:nvSpPr>
+        <p:spPr>
+          <a:xfrm>
+            <a:off x="777240" y="5504688"/>
+            <a:ext cx="10698480" cy="384048"/>
           </a:xfrm>
           <a:prstGeom prst="roundRect">
             <a:avLst>
-              <a:gd name="adj" fmla="val 16000"/>
+              <a:gd name="adj" fmla="val 14286"/>
             </a:avLst>
           </a:prstGeom>
           <a:solidFill>
@@ -2174,14 +4478,14 @@
       </p:sp>
       <p:sp>
         <p:nvSpPr>
-          <p:cNvPr id="10" name="Text 8"/>
-          <p:cNvSpPr/>
-          <p:nvPr/>
-        </p:nvSpPr>
-        <p:spPr>
-          <a:xfrm>
-            <a:off x="1143000" y="3511296"/>
-            <a:ext cx="9509760" cy="182880"/>
+          <p:cNvPr id="25" name="Text 23"/>
+          <p:cNvSpPr/>
+          <p:nvPr/>
+        </p:nvSpPr>
+        <p:spPr>
+          <a:xfrm>
+            <a:off x="1005840" y="5596128"/>
+            <a:ext cx="10149840" cy="164592"/>
           </a:xfrm>
           <a:prstGeom prst="rect">
             <a:avLst/>
@@ -2199,14 +4503,14 @@
               <a:buNone/>
             </a:pPr>
             <a:r>
-              <a:rPr lang="en-US" sz="1500" dirty="0">
+              <a:rPr lang="en-US" sz="1250" dirty="0">
                 <a:solidFill>
                   <a:srgbClr val="102A43"/>
                 </a:solidFill>
               </a:rPr>
               <a:t>Een punt schrijf je als (Q; P), bijvoorbeeld (300; 2,00).</a:t>
             </a:r>
-            <a:endParaRPr lang="en-US" sz="1500" dirty="0"/>
+            <a:endParaRPr lang="en-US" sz="1250" dirty="0"/>
           </a:p>
         </p:txBody>
       </p:sp>
@@ -2360,12 +4664,526 @@
         </p:nvSpPr>
         <p:spPr>
           <a:xfrm>
-            <a:off x="914400" y="1965960"/>
-            <a:ext cx="10058400" cy="457200"/>
+            <a:off x="3108960" y="1828800"/>
+            <a:ext cx="5669280" cy="2377440"/>
+          </a:xfrm>
+          <a:prstGeom prst="rect">
+            <a:avLst/>
+          </a:prstGeom>
+          <a:solidFill>
+            <a:srgbClr val="FFFFFF"/>
+          </a:solidFill>
+          <a:ln w="12700">
+            <a:solidFill>
+              <a:srgbClr val="CBD5E1"/>
+            </a:solidFill>
+            <a:prstDash val="solid"/>
+          </a:ln>
+        </p:spPr>
+      </p:sp>
+      <p:sp>
+        <p:nvSpPr>
+          <p:cNvPr id="6" name="Shape 4"/>
+          <p:cNvSpPr/>
+          <p:nvPr/>
+        </p:nvSpPr>
+        <p:spPr>
+          <a:xfrm>
+            <a:off x="3611880" y="3794760"/>
+            <a:ext cx="4892040" cy="0"/>
+          </a:xfrm>
+          <a:prstGeom prst="line">
+            <a:avLst/>
+          </a:prstGeom>
+          <a:noFill/>
+          <a:ln w="17780">
+            <a:solidFill>
+              <a:srgbClr val="102A43"/>
+            </a:solidFill>
+            <a:prstDash val="solid"/>
+          </a:ln>
+        </p:spPr>
+      </p:sp>
+      <p:sp>
+        <p:nvSpPr>
+          <p:cNvPr id="7" name="Shape 5"/>
+          <p:cNvSpPr/>
+          <p:nvPr/>
+        </p:nvSpPr>
+        <p:spPr>
+          <a:xfrm>
+            <a:off x="3611880" y="3794760"/>
+            <a:ext cx="0" cy="-1691640"/>
+          </a:xfrm>
+          <a:prstGeom prst="line">
+            <a:avLst/>
+          </a:prstGeom>
+          <a:noFill/>
+          <a:ln w="17780">
+            <a:solidFill>
+              <a:srgbClr val="102A43"/>
+            </a:solidFill>
+            <a:prstDash val="solid"/>
+          </a:ln>
+        </p:spPr>
+      </p:sp>
+      <p:sp>
+        <p:nvSpPr>
+          <p:cNvPr id="8" name="Text 6"/>
+          <p:cNvSpPr/>
+          <p:nvPr/>
+        </p:nvSpPr>
+        <p:spPr>
+          <a:xfrm>
+            <a:off x="3246120" y="1975104"/>
+            <a:ext cx="228600" cy="182880"/>
+          </a:xfrm>
+          <a:prstGeom prst="rect">
+            <a:avLst/>
+          </a:prstGeom>
+          <a:noFill/>
+          <a:ln/>
+        </p:spPr>
+        <p:txBody>
+          <a:bodyPr wrap="square" lIns="0" tIns="0" rIns="0" bIns="0" rtlCol="0" anchor="ctr"/>
+          <a:lstStyle/>
+          <a:p>
+            <a:pPr indent="0" marL="0">
+              <a:buNone/>
+            </a:pPr>
+            <a:r>
+              <a:rPr lang="en-US" sz="1200" b="1" dirty="0">
+                <a:solidFill>
+                  <a:srgbClr val="102A43"/>
+                </a:solidFill>
+              </a:rPr>
+              <a:t>P</a:t>
+            </a:r>
+            <a:endParaRPr lang="en-US" sz="1200" dirty="0"/>
+          </a:p>
+        </p:txBody>
+      </p:sp>
+      <p:sp>
+        <p:nvSpPr>
+          <p:cNvPr id="9" name="Text 7"/>
+          <p:cNvSpPr/>
+          <p:nvPr/>
+        </p:nvSpPr>
+        <p:spPr>
+          <a:xfrm>
+            <a:off x="8394192" y="3950208"/>
+            <a:ext cx="228600" cy="182880"/>
+          </a:xfrm>
+          <a:prstGeom prst="rect">
+            <a:avLst/>
+          </a:prstGeom>
+          <a:noFill/>
+          <a:ln/>
+        </p:spPr>
+        <p:txBody>
+          <a:bodyPr wrap="square" lIns="0" tIns="0" rIns="0" bIns="0" rtlCol="0" anchor="ctr"/>
+          <a:lstStyle/>
+          <a:p>
+            <a:pPr indent="0" marL="0">
+              <a:buNone/>
+            </a:pPr>
+            <a:r>
+              <a:rPr lang="en-US" sz="1200" b="1" dirty="0">
+                <a:solidFill>
+                  <a:srgbClr val="102A43"/>
+                </a:solidFill>
+              </a:rPr>
+              <a:t>Q</a:t>
+            </a:r>
+            <a:endParaRPr lang="en-US" sz="1200" dirty="0"/>
+          </a:p>
+        </p:txBody>
+      </p:sp>
+      <p:sp>
+        <p:nvSpPr>
+          <p:cNvPr id="10" name="Shape 8"/>
+          <p:cNvSpPr/>
+          <p:nvPr/>
+        </p:nvSpPr>
+        <p:spPr>
+          <a:xfrm>
+            <a:off x="4005072" y="2395728"/>
+            <a:ext cx="822960" cy="365760"/>
+          </a:xfrm>
+          <a:prstGeom prst="line">
+            <a:avLst/>
+          </a:prstGeom>
+          <a:noFill/>
+          <a:ln w="30480">
+            <a:solidFill>
+              <a:srgbClr val="2F7D4A"/>
+            </a:solidFill>
+            <a:prstDash val="solid"/>
+          </a:ln>
+        </p:spPr>
+      </p:sp>
+      <p:sp>
+        <p:nvSpPr>
+          <p:cNvPr id="11" name="Shape 9"/>
+          <p:cNvSpPr/>
+          <p:nvPr/>
+        </p:nvSpPr>
+        <p:spPr>
+          <a:xfrm>
+            <a:off x="4828032" y="2761488"/>
+            <a:ext cx="822960" cy="365760"/>
+          </a:xfrm>
+          <a:prstGeom prst="line">
+            <a:avLst/>
+          </a:prstGeom>
+          <a:noFill/>
+          <a:ln w="30480">
+            <a:solidFill>
+              <a:srgbClr val="2F7D4A"/>
+            </a:solidFill>
+            <a:prstDash val="solid"/>
+          </a:ln>
+        </p:spPr>
+      </p:sp>
+      <p:sp>
+        <p:nvSpPr>
+          <p:cNvPr id="12" name="Shape 10"/>
+          <p:cNvSpPr/>
+          <p:nvPr/>
+        </p:nvSpPr>
+        <p:spPr>
+          <a:xfrm>
+            <a:off x="5650992" y="3127248"/>
+            <a:ext cx="822960" cy="365760"/>
+          </a:xfrm>
+          <a:prstGeom prst="line">
+            <a:avLst/>
+          </a:prstGeom>
+          <a:noFill/>
+          <a:ln w="30480">
+            <a:solidFill>
+              <a:srgbClr val="2F7D4A"/>
+            </a:solidFill>
+            <a:prstDash val="solid"/>
+          </a:ln>
+        </p:spPr>
+      </p:sp>
+      <p:sp>
+        <p:nvSpPr>
+          <p:cNvPr id="13" name="Shape 11"/>
+          <p:cNvSpPr/>
+          <p:nvPr/>
+        </p:nvSpPr>
+        <p:spPr>
+          <a:xfrm>
+            <a:off x="6473952" y="3493008"/>
+            <a:ext cx="822960" cy="365760"/>
+          </a:xfrm>
+          <a:prstGeom prst="line">
+            <a:avLst/>
+          </a:prstGeom>
+          <a:noFill/>
+          <a:ln w="30480">
+            <a:solidFill>
+              <a:srgbClr val="2F7D4A"/>
+            </a:solidFill>
+            <a:prstDash val="solid"/>
+          </a:ln>
+        </p:spPr>
+      </p:sp>
+      <p:sp>
+        <p:nvSpPr>
+          <p:cNvPr id="14" name="Shape 12"/>
+          <p:cNvSpPr/>
+          <p:nvPr/>
+        </p:nvSpPr>
+        <p:spPr>
+          <a:xfrm>
+            <a:off x="3963924" y="2354580"/>
+            <a:ext cx="82296" cy="82296"/>
+          </a:xfrm>
+          <a:prstGeom prst="ellipse">
+            <a:avLst/>
+          </a:prstGeom>
+          <a:solidFill>
+            <a:srgbClr val="B45309"/>
+          </a:solidFill>
+          <a:ln w="12700">
+            <a:solidFill>
+              <a:srgbClr val="FFFFFF"/>
+            </a:solidFill>
+            <a:prstDash val="solid"/>
+          </a:ln>
+        </p:spPr>
+      </p:sp>
+      <p:sp>
+        <p:nvSpPr>
+          <p:cNvPr id="15" name="Shape 13"/>
+          <p:cNvSpPr/>
+          <p:nvPr/>
+        </p:nvSpPr>
+        <p:spPr>
+          <a:xfrm>
+            <a:off x="4786884" y="2720340"/>
+            <a:ext cx="82296" cy="82296"/>
+          </a:xfrm>
+          <a:prstGeom prst="ellipse">
+            <a:avLst/>
+          </a:prstGeom>
+          <a:solidFill>
+            <a:srgbClr val="B45309"/>
+          </a:solidFill>
+          <a:ln w="12700">
+            <a:solidFill>
+              <a:srgbClr val="FFFFFF"/>
+            </a:solidFill>
+            <a:prstDash val="solid"/>
+          </a:ln>
+        </p:spPr>
+      </p:sp>
+      <p:sp>
+        <p:nvSpPr>
+          <p:cNvPr id="16" name="Shape 14"/>
+          <p:cNvSpPr/>
+          <p:nvPr/>
+        </p:nvSpPr>
+        <p:spPr>
+          <a:xfrm>
+            <a:off x="5609844" y="3086100"/>
+            <a:ext cx="82296" cy="82296"/>
+          </a:xfrm>
+          <a:prstGeom prst="ellipse">
+            <a:avLst/>
+          </a:prstGeom>
+          <a:solidFill>
+            <a:srgbClr val="B45309"/>
+          </a:solidFill>
+          <a:ln w="12700">
+            <a:solidFill>
+              <a:srgbClr val="FFFFFF"/>
+            </a:solidFill>
+            <a:prstDash val="solid"/>
+          </a:ln>
+        </p:spPr>
+      </p:sp>
+      <p:sp>
+        <p:nvSpPr>
+          <p:cNvPr id="17" name="Text 15"/>
+          <p:cNvSpPr/>
+          <p:nvPr/>
+        </p:nvSpPr>
+        <p:spPr>
+          <a:xfrm>
+            <a:off x="5760720" y="2944368"/>
+            <a:ext cx="1097280" cy="182880"/>
+          </a:xfrm>
+          <a:prstGeom prst="rect">
+            <a:avLst/>
+          </a:prstGeom>
+          <a:noFill/>
+          <a:ln/>
+        </p:spPr>
+        <p:txBody>
+          <a:bodyPr wrap="square" lIns="0" tIns="0" rIns="0" bIns="0" rtlCol="0" anchor="ctr"/>
+          <a:lstStyle/>
+          <a:p>
+            <a:pPr indent="0" marL="0">
+              <a:buNone/>
+            </a:pPr>
+            <a:r>
+              <a:rPr lang="en-US" sz="900" dirty="0">
+                <a:solidFill>
+                  <a:srgbClr val="102A43"/>
+                </a:solidFill>
+              </a:rPr>
+              <a:t>(300; 2,00)</a:t>
+            </a:r>
+            <a:endParaRPr lang="en-US" sz="900" dirty="0"/>
+          </a:p>
+        </p:txBody>
+      </p:sp>
+      <p:sp>
+        <p:nvSpPr>
+          <p:cNvPr id="18" name="Shape 16"/>
+          <p:cNvSpPr/>
+          <p:nvPr/>
+        </p:nvSpPr>
+        <p:spPr>
+          <a:xfrm>
+            <a:off x="6432804" y="3451860"/>
+            <a:ext cx="82296" cy="82296"/>
+          </a:xfrm>
+          <a:prstGeom prst="ellipse">
+            <a:avLst/>
+          </a:prstGeom>
+          <a:solidFill>
+            <a:srgbClr val="B45309"/>
+          </a:solidFill>
+          <a:ln w="12700">
+            <a:solidFill>
+              <a:srgbClr val="FFFFFF"/>
+            </a:solidFill>
+            <a:prstDash val="solid"/>
+          </a:ln>
+        </p:spPr>
+      </p:sp>
+      <p:sp>
+        <p:nvSpPr>
+          <p:cNvPr id="19" name="Shape 17"/>
+          <p:cNvSpPr/>
+          <p:nvPr/>
+        </p:nvSpPr>
+        <p:spPr>
+          <a:xfrm>
+            <a:off x="7255764" y="3817620"/>
+            <a:ext cx="82296" cy="82296"/>
+          </a:xfrm>
+          <a:prstGeom prst="ellipse">
+            <a:avLst/>
+          </a:prstGeom>
+          <a:solidFill>
+            <a:srgbClr val="B45309"/>
+          </a:solidFill>
+          <a:ln w="12700">
+            <a:solidFill>
+              <a:srgbClr val="FFFFFF"/>
+            </a:solidFill>
+            <a:prstDash val="solid"/>
+          </a:ln>
+        </p:spPr>
+      </p:sp>
+      <p:sp>
+        <p:nvSpPr>
+          <p:cNvPr id="20" name="Shape 18"/>
+          <p:cNvSpPr/>
+          <p:nvPr/>
+        </p:nvSpPr>
+        <p:spPr>
+          <a:xfrm>
+            <a:off x="3611880" y="2980944"/>
+            <a:ext cx="2404872" cy="0"/>
+          </a:xfrm>
+          <a:prstGeom prst="line">
+            <a:avLst/>
+          </a:prstGeom>
+          <a:noFill/>
+          <a:ln w="20320">
+            <a:solidFill>
+              <a:srgbClr val="8A2D0E"/>
+            </a:solidFill>
+            <a:prstDash val="solid"/>
+          </a:ln>
+        </p:spPr>
+      </p:sp>
+      <p:sp>
+        <p:nvSpPr>
+          <p:cNvPr id="21" name="Shape 19"/>
+          <p:cNvSpPr/>
+          <p:nvPr/>
+        </p:nvSpPr>
+        <p:spPr>
+          <a:xfrm>
+            <a:off x="6016752" y="2980944"/>
+            <a:ext cx="0" cy="813816"/>
+          </a:xfrm>
+          <a:prstGeom prst="line">
+            <a:avLst/>
+          </a:prstGeom>
+          <a:noFill/>
+          <a:ln w="20320">
+            <a:solidFill>
+              <a:srgbClr val="8A2D0E"/>
+            </a:solidFill>
+            <a:prstDash val="solid"/>
+          </a:ln>
+        </p:spPr>
+      </p:sp>
+      <p:sp>
+        <p:nvSpPr>
+          <p:cNvPr id="22" name="Text 20"/>
+          <p:cNvSpPr/>
+          <p:nvPr/>
+        </p:nvSpPr>
+        <p:spPr>
+          <a:xfrm>
+            <a:off x="3749040" y="2761488"/>
+            <a:ext cx="822960" cy="164592"/>
+          </a:xfrm>
+          <a:prstGeom prst="rect">
+            <a:avLst/>
+          </a:prstGeom>
+          <a:noFill/>
+          <a:ln/>
+        </p:spPr>
+        <p:txBody>
+          <a:bodyPr wrap="square" lIns="0" tIns="0" rIns="0" bIns="0" rtlCol="0" anchor="ctr"/>
+          <a:lstStyle/>
+          <a:p>
+            <a:pPr indent="0" marL="0">
+              <a:buNone/>
+            </a:pPr>
+            <a:r>
+              <a:rPr lang="en-US" sz="850" dirty="0">
+                <a:solidFill>
+                  <a:srgbClr val="8A2D0E"/>
+                </a:solidFill>
+              </a:rPr>
+              <a:t>EUR 1,75</a:t>
+            </a:r>
+            <a:endParaRPr lang="en-US" sz="850" dirty="0"/>
+          </a:p>
+        </p:txBody>
+      </p:sp>
+      <p:sp>
+        <p:nvSpPr>
+          <p:cNvPr id="23" name="Text 21"/>
+          <p:cNvSpPr/>
+          <p:nvPr/>
+        </p:nvSpPr>
+        <p:spPr>
+          <a:xfrm>
+            <a:off x="6089904" y="3584448"/>
+            <a:ext cx="822960" cy="164592"/>
+          </a:xfrm>
+          <a:prstGeom prst="rect">
+            <a:avLst/>
+          </a:prstGeom>
+          <a:noFill/>
+          <a:ln/>
+        </p:spPr>
+        <p:txBody>
+          <a:bodyPr wrap="square" lIns="0" tIns="0" rIns="0" bIns="0" rtlCol="0" anchor="ctr"/>
+          <a:lstStyle/>
+          <a:p>
+            <a:pPr indent="0" marL="0">
+              <a:buNone/>
+            </a:pPr>
+            <a:r>
+              <a:rPr lang="en-US" sz="850" dirty="0">
+                <a:solidFill>
+                  <a:srgbClr val="8A2D0E"/>
+                </a:solidFill>
+              </a:rPr>
+              <a:t>Q ~ 350</a:t>
+            </a:r>
+            <a:endParaRPr lang="en-US" sz="850" dirty="0"/>
+          </a:p>
+        </p:txBody>
+      </p:sp>
+      <p:sp>
+        <p:nvSpPr>
+          <p:cNvPr id="24" name="Shape 22"/>
+          <p:cNvSpPr/>
+          <p:nvPr/>
+        </p:nvSpPr>
+        <p:spPr>
+          <a:xfrm>
+            <a:off x="777240" y="4480560"/>
+            <a:ext cx="10698480" cy="384048"/>
           </a:xfrm>
           <a:prstGeom prst="roundRect">
             <a:avLst>
-              <a:gd name="adj" fmla="val 16000"/>
+              <a:gd name="adj" fmla="val 14286"/>
             </a:avLst>
           </a:prstGeom>
           <a:solidFill>
@@ -2381,14 +5199,14 @@
       </p:sp>
       <p:sp>
         <p:nvSpPr>
-          <p:cNvPr id="6" name="Text 4"/>
-          <p:cNvSpPr/>
-          <p:nvPr/>
-        </p:nvSpPr>
-        <p:spPr>
-          <a:xfrm>
-            <a:off x="1143000" y="2084832"/>
-            <a:ext cx="9509760" cy="182880"/>
+          <p:cNvPr id="25" name="Text 23"/>
+          <p:cNvSpPr/>
+          <p:nvPr/>
+        </p:nvSpPr>
+        <p:spPr>
+          <a:xfrm>
+            <a:off x="1005840" y="4572000"/>
+            <a:ext cx="10149840" cy="164592"/>
           </a:xfrm>
           <a:prstGeom prst="rect">
             <a:avLst/>
@@ -2406,31 +5224,31 @@
               <a:buNone/>
             </a:pPr>
             <a:r>
-              <a:rPr lang="en-US" sz="1500" dirty="0">
+              <a:rPr lang="en-US" sz="1250" dirty="0">
                 <a:solidFill>
                   <a:srgbClr val="102A43"/>
                 </a:solidFill>
               </a:rPr>
               <a:t>Zoek EUR 1,75 op de prijsas.</a:t>
             </a:r>
-            <a:endParaRPr lang="en-US" sz="1500" dirty="0"/>
-          </a:p>
-        </p:txBody>
-      </p:sp>
-      <p:sp>
-        <p:nvSpPr>
-          <p:cNvPr id="7" name="Shape 5"/>
-          <p:cNvSpPr/>
-          <p:nvPr/>
-        </p:nvSpPr>
-        <p:spPr>
-          <a:xfrm>
-            <a:off x="914400" y="2679192"/>
-            <a:ext cx="10058400" cy="457200"/>
+            <a:endParaRPr lang="en-US" sz="1250" dirty="0"/>
+          </a:p>
+        </p:txBody>
+      </p:sp>
+      <p:sp>
+        <p:nvSpPr>
+          <p:cNvPr id="26" name="Shape 24"/>
+          <p:cNvSpPr/>
+          <p:nvPr/>
+        </p:nvSpPr>
+        <p:spPr>
+          <a:xfrm>
+            <a:off x="777240" y="4992624"/>
+            <a:ext cx="10698480" cy="384048"/>
           </a:xfrm>
           <a:prstGeom prst="roundRect">
             <a:avLst>
-              <a:gd name="adj" fmla="val 16000"/>
+              <a:gd name="adj" fmla="val 14286"/>
             </a:avLst>
           </a:prstGeom>
           <a:solidFill>
@@ -2446,14 +5264,14 @@
       </p:sp>
       <p:sp>
         <p:nvSpPr>
-          <p:cNvPr id="8" name="Text 6"/>
-          <p:cNvSpPr/>
-          <p:nvPr/>
-        </p:nvSpPr>
-        <p:spPr>
-          <a:xfrm>
-            <a:off x="1143000" y="2798064"/>
-            <a:ext cx="9509760" cy="182880"/>
+          <p:cNvPr id="27" name="Text 25"/>
+          <p:cNvSpPr/>
+          <p:nvPr/>
+        </p:nvSpPr>
+        <p:spPr>
+          <a:xfrm>
+            <a:off x="1005840" y="5084064"/>
+            <a:ext cx="10149840" cy="164592"/>
           </a:xfrm>
           <a:prstGeom prst="rect">
             <a:avLst/>
@@ -2471,31 +5289,31 @@
               <a:buNone/>
             </a:pPr>
             <a:r>
-              <a:rPr lang="en-US" sz="1500" dirty="0">
+              <a:rPr lang="en-US" sz="1250" dirty="0">
                 <a:solidFill>
                   <a:srgbClr val="102A43"/>
                 </a:solidFill>
               </a:rPr>
               <a:t>Trek een lijn naar de grafiek en lees Q af.</a:t>
             </a:r>
-            <a:endParaRPr lang="en-US" sz="1500" dirty="0"/>
-          </a:p>
-        </p:txBody>
-      </p:sp>
-      <p:sp>
-        <p:nvSpPr>
-          <p:cNvPr id="9" name="Shape 7"/>
-          <p:cNvSpPr/>
-          <p:nvPr/>
-        </p:nvSpPr>
-        <p:spPr>
-          <a:xfrm>
-            <a:off x="914400" y="3392424"/>
-            <a:ext cx="10058400" cy="457200"/>
+            <a:endParaRPr lang="en-US" sz="1250" dirty="0"/>
+          </a:p>
+        </p:txBody>
+      </p:sp>
+      <p:sp>
+        <p:nvSpPr>
+          <p:cNvPr id="28" name="Shape 26"/>
+          <p:cNvSpPr/>
+          <p:nvPr/>
+        </p:nvSpPr>
+        <p:spPr>
+          <a:xfrm>
+            <a:off x="777240" y="5504688"/>
+            <a:ext cx="10698480" cy="384048"/>
           </a:xfrm>
           <a:prstGeom prst="roundRect">
             <a:avLst>
-              <a:gd name="adj" fmla="val 16000"/>
+              <a:gd name="adj" fmla="val 14286"/>
             </a:avLst>
           </a:prstGeom>
           <a:solidFill>
@@ -2511,14 +5329,14 @@
       </p:sp>
       <p:sp>
         <p:nvSpPr>
-          <p:cNvPr id="10" name="Text 8"/>
-          <p:cNvSpPr/>
-          <p:nvPr/>
-        </p:nvSpPr>
-        <p:spPr>
-          <a:xfrm>
-            <a:off x="1143000" y="3511296"/>
-            <a:ext cx="9509760" cy="182880"/>
+          <p:cNvPr id="29" name="Text 27"/>
+          <p:cNvSpPr/>
+          <p:nvPr/>
+        </p:nvSpPr>
+        <p:spPr>
+          <a:xfrm>
+            <a:off x="1005840" y="5596128"/>
+            <a:ext cx="10149840" cy="164592"/>
           </a:xfrm>
           <a:prstGeom prst="rect">
             <a:avLst/>
@@ -2536,14 +5354,14 @@
               <a:buNone/>
             </a:pPr>
             <a:r>
-              <a:rPr lang="en-US" sz="1500" dirty="0">
+              <a:rPr lang="en-US" sz="1250" dirty="0">
                 <a:solidFill>
                   <a:srgbClr val="102A43"/>
                 </a:solidFill>
               </a:rPr>
               <a:t>Tussen 400 en 300 ligt ongeveer 350.</a:t>
             </a:r>
-            <a:endParaRPr lang="en-US" sz="1500" dirty="0"/>
+            <a:endParaRPr lang="en-US" sz="1250" dirty="0"/>
           </a:p>
         </p:txBody>
       </p:sp>
@@ -2697,12 +5515,378 @@
         </p:nvSpPr>
         <p:spPr>
           <a:xfrm>
-            <a:off x="914400" y="1965960"/>
-            <a:ext cx="10058400" cy="457200"/>
+            <a:off x="1828800" y="1874520"/>
+            <a:ext cx="3959352" cy="2240280"/>
+          </a:xfrm>
+          <a:prstGeom prst="rect">
+            <a:avLst/>
+          </a:prstGeom>
+          <a:solidFill>
+            <a:srgbClr val="FFFFFF"/>
+          </a:solidFill>
+          <a:ln w="12700">
+            <a:solidFill>
+              <a:srgbClr val="CBD5E1"/>
+            </a:solidFill>
+            <a:prstDash val="solid"/>
+          </a:ln>
+        </p:spPr>
+      </p:sp>
+      <p:sp>
+        <p:nvSpPr>
+          <p:cNvPr id="6" name="Text 4"/>
+          <p:cNvSpPr/>
+          <p:nvPr/>
+        </p:nvSpPr>
+        <p:spPr>
+          <a:xfrm>
+            <a:off x="1938528" y="1984248"/>
+            <a:ext cx="3739896" cy="182880"/>
+          </a:xfrm>
+          <a:prstGeom prst="rect">
+            <a:avLst/>
+          </a:prstGeom>
+          <a:noFill/>
+          <a:ln/>
+        </p:spPr>
+        <p:txBody>
+          <a:bodyPr wrap="square" lIns="0" tIns="0" rIns="0" bIns="0" rtlCol="0" anchor="ctr"/>
+          <a:lstStyle/>
+          <a:p>
+            <a:pPr indent="0" marL="0">
+              <a:buNone/>
+            </a:pPr>
+            <a:r>
+              <a:rPr lang="en-US" sz="1000" b="1" dirty="0">
+                <a:solidFill>
+                  <a:srgbClr val="102A43"/>
+                </a:solidFill>
+              </a:rPr>
+              <a:t>as vanaf 0</a:t>
+            </a:r>
+            <a:endParaRPr lang="en-US" sz="1000" dirty="0"/>
+          </a:p>
+        </p:txBody>
+      </p:sp>
+      <p:sp>
+        <p:nvSpPr>
+          <p:cNvPr id="7" name="Shape 5"/>
+          <p:cNvSpPr/>
+          <p:nvPr/>
+        </p:nvSpPr>
+        <p:spPr>
+          <a:xfrm>
+            <a:off x="2176272" y="2532888"/>
+            <a:ext cx="420624" cy="1261872"/>
+          </a:xfrm>
+          <a:prstGeom prst="rect">
+            <a:avLst/>
+          </a:prstGeom>
+          <a:solidFill>
+            <a:srgbClr val="2F7D4A"/>
+          </a:solidFill>
+          <a:ln w="12700">
+            <a:solidFill>
+              <a:srgbClr val="2F7D4A"/>
+            </a:solidFill>
+            <a:prstDash val="solid"/>
+          </a:ln>
+        </p:spPr>
+      </p:sp>
+      <p:sp>
+        <p:nvSpPr>
+          <p:cNvPr id="8" name="Text 6"/>
+          <p:cNvSpPr/>
+          <p:nvPr/>
+        </p:nvSpPr>
+        <p:spPr>
+          <a:xfrm>
+            <a:off x="2148840" y="3877056"/>
+            <a:ext cx="502920" cy="146304"/>
+          </a:xfrm>
+          <a:prstGeom prst="rect">
+            <a:avLst/>
+          </a:prstGeom>
+          <a:noFill/>
+          <a:ln/>
+        </p:spPr>
+        <p:txBody>
+          <a:bodyPr wrap="square" lIns="0" tIns="0" rIns="0" bIns="0" rtlCol="0" anchor="ctr"/>
+          <a:lstStyle/>
+          <a:p>
+            <a:pPr indent="0" marL="0">
+              <a:buNone/>
+            </a:pPr>
+            <a:r>
+              <a:rPr lang="en-US" sz="850" dirty="0">
+                <a:solidFill>
+                  <a:srgbClr val="102A43"/>
+                </a:solidFill>
+              </a:rPr>
+              <a:t>520</a:t>
+            </a:r>
+            <a:endParaRPr lang="en-US" sz="850" dirty="0"/>
+          </a:p>
+        </p:txBody>
+      </p:sp>
+      <p:sp>
+        <p:nvSpPr>
+          <p:cNvPr id="9" name="Shape 7"/>
+          <p:cNvSpPr/>
+          <p:nvPr/>
+        </p:nvSpPr>
+        <p:spPr>
+          <a:xfrm>
+            <a:off x="2953512" y="2587752"/>
+            <a:ext cx="420624" cy="1207008"/>
+          </a:xfrm>
+          <a:prstGeom prst="rect">
+            <a:avLst/>
+          </a:prstGeom>
+          <a:solidFill>
+            <a:srgbClr val="2F7D4A"/>
+          </a:solidFill>
+          <a:ln w="12700">
+            <a:solidFill>
+              <a:srgbClr val="2F7D4A"/>
+            </a:solidFill>
+            <a:prstDash val="solid"/>
+          </a:ln>
+        </p:spPr>
+      </p:sp>
+      <p:sp>
+        <p:nvSpPr>
+          <p:cNvPr id="10" name="Text 8"/>
+          <p:cNvSpPr/>
+          <p:nvPr/>
+        </p:nvSpPr>
+        <p:spPr>
+          <a:xfrm>
+            <a:off x="2926080" y="3877056"/>
+            <a:ext cx="502920" cy="146304"/>
+          </a:xfrm>
+          <a:prstGeom prst="rect">
+            <a:avLst/>
+          </a:prstGeom>
+          <a:noFill/>
+          <a:ln/>
+        </p:spPr>
+        <p:txBody>
+          <a:bodyPr wrap="square" lIns="0" tIns="0" rIns="0" bIns="0" rtlCol="0" anchor="ctr"/>
+          <a:lstStyle/>
+          <a:p>
+            <a:pPr indent="0" marL="0">
+              <a:buNone/>
+            </a:pPr>
+            <a:r>
+              <a:rPr lang="en-US" sz="850" dirty="0">
+                <a:solidFill>
+                  <a:srgbClr val="102A43"/>
+                </a:solidFill>
+              </a:rPr>
+              <a:t>500</a:t>
+            </a:r>
+            <a:endParaRPr lang="en-US" sz="850" dirty="0"/>
+          </a:p>
+        </p:txBody>
+      </p:sp>
+      <p:sp>
+        <p:nvSpPr>
+          <p:cNvPr id="11" name="Shape 9"/>
+          <p:cNvSpPr/>
+          <p:nvPr/>
+        </p:nvSpPr>
+        <p:spPr>
+          <a:xfrm>
+            <a:off x="6007608" y="1874520"/>
+            <a:ext cx="3959352" cy="2240280"/>
+          </a:xfrm>
+          <a:prstGeom prst="rect">
+            <a:avLst/>
+          </a:prstGeom>
+          <a:solidFill>
+            <a:srgbClr val="FFFFFF"/>
+          </a:solidFill>
+          <a:ln w="12700">
+            <a:solidFill>
+              <a:srgbClr val="CBD5E1"/>
+            </a:solidFill>
+            <a:prstDash val="solid"/>
+          </a:ln>
+        </p:spPr>
+      </p:sp>
+      <p:sp>
+        <p:nvSpPr>
+          <p:cNvPr id="12" name="Text 10"/>
+          <p:cNvSpPr/>
+          <p:nvPr/>
+        </p:nvSpPr>
+        <p:spPr>
+          <a:xfrm>
+            <a:off x="6117336" y="1984248"/>
+            <a:ext cx="3739896" cy="182880"/>
+          </a:xfrm>
+          <a:prstGeom prst="rect">
+            <a:avLst/>
+          </a:prstGeom>
+          <a:noFill/>
+          <a:ln/>
+        </p:spPr>
+        <p:txBody>
+          <a:bodyPr wrap="square" lIns="0" tIns="0" rIns="0" bIns="0" rtlCol="0" anchor="ctr"/>
+          <a:lstStyle/>
+          <a:p>
+            <a:pPr indent="0" marL="0">
+              <a:buNone/>
+            </a:pPr>
+            <a:r>
+              <a:rPr lang="en-US" sz="1000" b="1" dirty="0">
+                <a:solidFill>
+                  <a:srgbClr val="102A43"/>
+                </a:solidFill>
+              </a:rPr>
+              <a:t>as vanaf 490</a:t>
+            </a:r>
+            <a:endParaRPr lang="en-US" sz="1000" dirty="0"/>
+          </a:p>
+        </p:txBody>
+      </p:sp>
+      <p:sp>
+        <p:nvSpPr>
+          <p:cNvPr id="13" name="Shape 11"/>
+          <p:cNvSpPr/>
+          <p:nvPr/>
+        </p:nvSpPr>
+        <p:spPr>
+          <a:xfrm>
+            <a:off x="6355080" y="2532888"/>
+            <a:ext cx="420624" cy="1261872"/>
+          </a:xfrm>
+          <a:prstGeom prst="rect">
+            <a:avLst/>
+          </a:prstGeom>
+          <a:solidFill>
+            <a:srgbClr val="2F7D4A"/>
+          </a:solidFill>
+          <a:ln w="12700">
+            <a:solidFill>
+              <a:srgbClr val="2F7D4A"/>
+            </a:solidFill>
+            <a:prstDash val="solid"/>
+          </a:ln>
+        </p:spPr>
+      </p:sp>
+      <p:sp>
+        <p:nvSpPr>
+          <p:cNvPr id="14" name="Text 12"/>
+          <p:cNvSpPr/>
+          <p:nvPr/>
+        </p:nvSpPr>
+        <p:spPr>
+          <a:xfrm>
+            <a:off x="6327648" y="3877056"/>
+            <a:ext cx="502920" cy="146304"/>
+          </a:xfrm>
+          <a:prstGeom prst="rect">
+            <a:avLst/>
+          </a:prstGeom>
+          <a:noFill/>
+          <a:ln/>
+        </p:spPr>
+        <p:txBody>
+          <a:bodyPr wrap="square" lIns="0" tIns="0" rIns="0" bIns="0" rtlCol="0" anchor="ctr"/>
+          <a:lstStyle/>
+          <a:p>
+            <a:pPr indent="0" marL="0">
+              <a:buNone/>
+            </a:pPr>
+            <a:r>
+              <a:rPr lang="en-US" sz="850" dirty="0">
+                <a:solidFill>
+                  <a:srgbClr val="102A43"/>
+                </a:solidFill>
+              </a:rPr>
+              <a:t>520</a:t>
+            </a:r>
+            <a:endParaRPr lang="en-US" sz="850" dirty="0"/>
+          </a:p>
+        </p:txBody>
+      </p:sp>
+      <p:sp>
+        <p:nvSpPr>
+          <p:cNvPr id="15" name="Shape 13"/>
+          <p:cNvSpPr/>
+          <p:nvPr/>
+        </p:nvSpPr>
+        <p:spPr>
+          <a:xfrm>
+            <a:off x="7132320" y="3328416"/>
+            <a:ext cx="420624" cy="466344"/>
+          </a:xfrm>
+          <a:prstGeom prst="rect">
+            <a:avLst/>
+          </a:prstGeom>
+          <a:solidFill>
+            <a:srgbClr val="2F7D4A"/>
+          </a:solidFill>
+          <a:ln w="12700">
+            <a:solidFill>
+              <a:srgbClr val="2F7D4A"/>
+            </a:solidFill>
+            <a:prstDash val="solid"/>
+          </a:ln>
+        </p:spPr>
+      </p:sp>
+      <p:sp>
+        <p:nvSpPr>
+          <p:cNvPr id="16" name="Text 14"/>
+          <p:cNvSpPr/>
+          <p:nvPr/>
+        </p:nvSpPr>
+        <p:spPr>
+          <a:xfrm>
+            <a:off x="7104888" y="3877056"/>
+            <a:ext cx="502920" cy="146304"/>
+          </a:xfrm>
+          <a:prstGeom prst="rect">
+            <a:avLst/>
+          </a:prstGeom>
+          <a:noFill/>
+          <a:ln/>
+        </p:spPr>
+        <p:txBody>
+          <a:bodyPr wrap="square" lIns="0" tIns="0" rIns="0" bIns="0" rtlCol="0" anchor="ctr"/>
+          <a:lstStyle/>
+          <a:p>
+            <a:pPr indent="0" marL="0">
+              <a:buNone/>
+            </a:pPr>
+            <a:r>
+              <a:rPr lang="en-US" sz="850" dirty="0">
+                <a:solidFill>
+                  <a:srgbClr val="102A43"/>
+                </a:solidFill>
+              </a:rPr>
+              <a:t>500</a:t>
+            </a:r>
+            <a:endParaRPr lang="en-US" sz="850" dirty="0"/>
+          </a:p>
+        </p:txBody>
+      </p:sp>
+      <p:sp>
+        <p:nvSpPr>
+          <p:cNvPr id="17" name="Shape 15"/>
+          <p:cNvSpPr/>
+          <p:nvPr/>
+        </p:nvSpPr>
+        <p:spPr>
+          <a:xfrm>
+            <a:off x="777240" y="4480560"/>
+            <a:ext cx="10698480" cy="384048"/>
           </a:xfrm>
           <a:prstGeom prst="roundRect">
             <a:avLst>
-              <a:gd name="adj" fmla="val 16000"/>
+              <a:gd name="adj" fmla="val 14286"/>
             </a:avLst>
           </a:prstGeom>
           <a:solidFill>
@@ -2718,14 +5902,14 @@
       </p:sp>
       <p:sp>
         <p:nvSpPr>
-          <p:cNvPr id="6" name="Text 4"/>
-          <p:cNvSpPr/>
-          <p:nvPr/>
-        </p:nvSpPr>
-        <p:spPr>
-          <a:xfrm>
-            <a:off x="1143000" y="2084832"/>
-            <a:ext cx="9509760" cy="182880"/>
+          <p:cNvPr id="18" name="Text 16"/>
+          <p:cNvSpPr/>
+          <p:nvPr/>
+        </p:nvSpPr>
+        <p:spPr>
+          <a:xfrm>
+            <a:off x="1005840" y="4572000"/>
+            <a:ext cx="10149840" cy="164592"/>
           </a:xfrm>
           <a:prstGeom prst="rect">
             <a:avLst/>
@@ -2743,31 +5927,31 @@
               <a:buNone/>
             </a:pPr>
             <a:r>
-              <a:rPr lang="en-US" sz="1500" dirty="0">
+              <a:rPr lang="en-US" sz="1250" dirty="0">
                 <a:solidFill>
                   <a:srgbClr val="102A43"/>
                 </a:solidFill>
               </a:rPr>
               <a:t>Controleer altijd of de as bij nul begint.</a:t>
             </a:r>
-            <a:endParaRPr lang="en-US" sz="1500" dirty="0"/>
-          </a:p>
-        </p:txBody>
-      </p:sp>
-      <p:sp>
-        <p:nvSpPr>
-          <p:cNvPr id="7" name="Shape 5"/>
-          <p:cNvSpPr/>
-          <p:nvPr/>
-        </p:nvSpPr>
-        <p:spPr>
-          <a:xfrm>
-            <a:off x="914400" y="2679192"/>
-            <a:ext cx="10058400" cy="457200"/>
+            <a:endParaRPr lang="en-US" sz="1250" dirty="0"/>
+          </a:p>
+        </p:txBody>
+      </p:sp>
+      <p:sp>
+        <p:nvSpPr>
+          <p:cNvPr id="19" name="Shape 17"/>
+          <p:cNvSpPr/>
+          <p:nvPr/>
+        </p:nvSpPr>
+        <p:spPr>
+          <a:xfrm>
+            <a:off x="777240" y="4992624"/>
+            <a:ext cx="10698480" cy="384048"/>
           </a:xfrm>
           <a:prstGeom prst="roundRect">
             <a:avLst>
-              <a:gd name="adj" fmla="val 16000"/>
+              <a:gd name="adj" fmla="val 14286"/>
             </a:avLst>
           </a:prstGeom>
           <a:solidFill>
@@ -2783,14 +5967,14 @@
       </p:sp>
       <p:sp>
         <p:nvSpPr>
-          <p:cNvPr id="8" name="Text 6"/>
-          <p:cNvSpPr/>
-          <p:nvPr/>
-        </p:nvSpPr>
-        <p:spPr>
-          <a:xfrm>
-            <a:off x="1143000" y="2798064"/>
-            <a:ext cx="9509760" cy="182880"/>
+          <p:cNvPr id="20" name="Text 18"/>
+          <p:cNvSpPr/>
+          <p:nvPr/>
+        </p:nvSpPr>
+        <p:spPr>
+          <a:xfrm>
+            <a:off x="1005840" y="5084064"/>
+            <a:ext cx="10149840" cy="164592"/>
           </a:xfrm>
           <a:prstGeom prst="rect">
             <a:avLst/>
@@ -2808,31 +5992,31 @@
               <a:buNone/>
             </a:pPr>
             <a:r>
-              <a:rPr lang="en-US" sz="1500" dirty="0">
+              <a:rPr lang="en-US" sz="1250" dirty="0">
                 <a:solidFill>
                   <a:srgbClr val="102A43"/>
                 </a:solidFill>
               </a:rPr>
               <a:t>Vraag welke twee waarden worden vergeleken.</a:t>
             </a:r>
-            <a:endParaRPr lang="en-US" sz="1500" dirty="0"/>
-          </a:p>
-        </p:txBody>
-      </p:sp>
-      <p:sp>
-        <p:nvSpPr>
-          <p:cNvPr id="9" name="Shape 7"/>
-          <p:cNvSpPr/>
-          <p:nvPr/>
-        </p:nvSpPr>
-        <p:spPr>
-          <a:xfrm>
-            <a:off x="914400" y="3392424"/>
-            <a:ext cx="10058400" cy="457200"/>
+            <a:endParaRPr lang="en-US" sz="1250" dirty="0"/>
+          </a:p>
+        </p:txBody>
+      </p:sp>
+      <p:sp>
+        <p:nvSpPr>
+          <p:cNvPr id="21" name="Shape 19"/>
+          <p:cNvSpPr/>
+          <p:nvPr/>
+        </p:nvSpPr>
+        <p:spPr>
+          <a:xfrm>
+            <a:off x="777240" y="5504688"/>
+            <a:ext cx="10698480" cy="384048"/>
           </a:xfrm>
           <a:prstGeom prst="roundRect">
             <a:avLst>
-              <a:gd name="adj" fmla="val 16000"/>
+              <a:gd name="adj" fmla="val 14286"/>
             </a:avLst>
           </a:prstGeom>
           <a:solidFill>
@@ -2848,14 +6032,14 @@
       </p:sp>
       <p:sp>
         <p:nvSpPr>
-          <p:cNvPr id="10" name="Text 8"/>
-          <p:cNvSpPr/>
-          <p:nvPr/>
-        </p:nvSpPr>
-        <p:spPr>
-          <a:xfrm>
-            <a:off x="1143000" y="3511296"/>
-            <a:ext cx="9509760" cy="182880"/>
+          <p:cNvPr id="22" name="Text 20"/>
+          <p:cNvSpPr/>
+          <p:nvPr/>
+        </p:nvSpPr>
+        <p:spPr>
+          <a:xfrm>
+            <a:off x="1005840" y="5596128"/>
+            <a:ext cx="10149840" cy="164592"/>
           </a:xfrm>
           <a:prstGeom prst="rect">
             <a:avLst/>
@@ -2873,14 +6057,14 @@
               <a:buNone/>
             </a:pPr>
             <a:r>
-              <a:rPr lang="en-US" sz="1500" dirty="0">
+              <a:rPr lang="en-US" sz="1250" dirty="0">
                 <a:solidFill>
                   <a:srgbClr val="102A43"/>
                 </a:solidFill>
               </a:rPr>
               <a:t>Een kop met procenten klopt alleen met de juiste basis.</a:t>
             </a:r>
-            <a:endParaRPr lang="en-US" sz="1500" dirty="0"/>
+            <a:endParaRPr lang="en-US" sz="1250" dirty="0"/>
           </a:p>
         </p:txBody>
       </p:sp>

</xml_diff>